<commit_message>
Add 'a day in the life' workflow slides to both decks
- Student deck: new slide 15 'A day with PhDapp' — 6 numbered steps
  (Morning → Bell → Tasks → Meetings → Chat & files → Friday) showing
  the typical student flow end-to-end. 16 slides total.
- Supervisor deck: new slide 17 'A day · as a supervisor' (Morning →
  Triage → 1:1 prep → Meeting → Reading → Friday) and new slide 18
  'A day · as a team advisor' (Open a student → Catch up → Meetings
  → Wellbeing → Suggest → Annual review). 19 slides total.
- New helper addStepCard() — circular number badge in module accent
  colour + bold step title + 2-line body. Reuses FS.body / FS.cardTitle
  so it inherits the homogenised typographic scale.

Visual QA: all three slides pass (cards stay above the footer; 2-line
bodies fit comfortably; no overflow).

Co-Authored-By: Claude Opus 4.7 (1M context) <noreply@anthropic.com>
</commit_message>
<xml_diff>
--- a/docs/PhDapp_Student_Overview.pptx
+++ b/docs/PhDapp_Student_Overview.pptx
@@ -20,9 +20,10 @@
     <p:sldId id="268" r:id="rId14"/>
     <p:sldId id="269" r:id="rId15"/>
     <p:sldId id="270" r:id="rId16"/>
+    <p:sldId id="271" r:id="rId17"/>
   </p:sldIdLst>
   <p:notesMasterIdLst>
-    <p:notesMasterId r:id="rId17"/>
+    <p:notesMasterId r:id="rId18"/>
   </p:notesMasterIdLst>
   <p:sldSz cx="12192000" cy="6858000"/>
   <p:notesSz cx="6858000" cy="12192000"/>
@@ -1068,6 +1069,94 @@
             <a:fld id="{F7021451-1387-4CA6-816F-3879F97B5CBC}" type="slidenum">
               <a:rPr lang="en-US"/>
               <a:t>15</a:t>
+            </a:fld>
+            <a:endParaRPr lang="en-US"/>
+          </a:p>
+        </p:txBody>
+      </p:sp>
+    </p:spTree>
+    <p:extLst>
+      <p:ext uri="{BB962C8B-B14F-4D97-AF65-F5344CB8AC3E}">
+        <p14:creationId xmlns:p14="http://schemas.microsoft.com/office/powerpoint/2010/main" val="1024086991"/>
+      </p:ext>
+    </p:extLst>
+  </p:cSld>
+  <p:clrMapOvr>
+    <a:masterClrMapping/>
+  </p:clrMapOvr>
+</p:notes>
+</file>
+
+<file path=ppt/notesSlides/notesSlide16.xml><?xml version="1.0" encoding="utf-8"?>
+<p:notes xmlns:a="http://schemas.openxmlformats.org/drawingml/2006/main" xmlns:r="http://schemas.openxmlformats.org/officeDocument/2006/relationships" xmlns:p="http://schemas.openxmlformats.org/presentationml/2006/main">
+  <p:cSld>
+    <p:spTree>
+      <p:nvGrpSpPr>
+        <p:cNvPr id="1" name=""/>
+        <p:cNvGrpSpPr/>
+        <p:nvPr/>
+      </p:nvGrpSpPr>
+      <p:grpSpPr>
+        <a:xfrm>
+          <a:off x="0" y="0"/>
+          <a:ext cx="0" cy="0"/>
+          <a:chOff x="0" y="0"/>
+          <a:chExt cx="0" cy="0"/>
+        </a:xfrm>
+      </p:grpSpPr>
+      <p:sp>
+        <p:nvSpPr>
+          <p:cNvPr id="2" name="Slide Image Placeholder 1"/>
+          <p:cNvSpPr>
+            <a:spLocks noGrp="1" noRot="1" noChangeAspect="1"/>
+          </p:cNvSpPr>
+          <p:nvPr>
+            <p:ph type="sldImg"/>
+          </p:nvPr>
+        </p:nvSpPr>
+        <p:spPr/>
+      </p:sp>
+      <p:sp>
+        <p:nvSpPr>
+          <p:cNvPr id="3" name="Notes Placeholder 2"/>
+          <p:cNvSpPr>
+            <a:spLocks noGrp="1"/>
+          </p:cNvSpPr>
+          <p:nvPr>
+            <p:ph type="body" idx="1"/>
+          </p:nvPr>
+        </p:nvSpPr>
+        <p:spPr/>
+        <p:txBody>
+          <a:bodyPr/>
+          <a:lstStyle/>
+          <a:p>
+            <a:r>
+              <a:rPr lang="en-US" dirty="0"/>
+              <a:t/>
+            </a:r>
+            <a:endParaRPr lang="en-US" dirty="0"/>
+          </a:p>
+        </p:txBody>
+      </p:sp>
+      <p:sp>
+        <p:nvSpPr>
+          <p:cNvPr id="4" name="Slide Number Placeholder 3"/>
+          <p:cNvSpPr>
+            <a:spLocks noGrp="1"/>
+          </p:cNvSpPr>
+          <p:nvPr>
+            <p:ph type="sldNum" sz="quarter" idx="10"/>
+          </p:nvPr>
+        </p:nvSpPr>
+        <p:spPr/>
+        <p:txBody>
+          <a:bodyPr/>
+          <a:lstStyle/>
+          <a:p>
+            <a:fld id="{F7021451-1387-4CA6-816F-3879F97B5CBC}" type="slidenum">
+              <a:rPr lang="en-US"/>
+              <a:t>16</a:t>
             </a:fld>
             <a:endParaRPr lang="en-US"/>
           </a:p>
@@ -2927,7 +3016,7 @@
                 <a:ea typeface="Inter" pitchFamily="34" charset="-122"/>
                 <a:cs typeface="Inter" pitchFamily="34" charset="-120"/>
               </a:rPr>
-              <a:t>10 / 15</a:t>
+              <a:t>10 / 16</a:t>
             </a:r>
             <a:endParaRPr lang="en-US" sz="1300" dirty="0"/>
           </a:p>
@@ -3596,7 +3685,7 @@
                 <a:ea typeface="Inter" pitchFamily="34" charset="-122"/>
                 <a:cs typeface="Inter" pitchFamily="34" charset="-120"/>
               </a:rPr>
-              <a:t>11 / 15</a:t>
+              <a:t>11 / 16</a:t>
             </a:r>
             <a:endParaRPr lang="en-US" sz="1300" dirty="0"/>
           </a:p>
@@ -4265,7 +4354,7 @@
                 <a:ea typeface="Inter" pitchFamily="34" charset="-122"/>
                 <a:cs typeface="Inter" pitchFamily="34" charset="-120"/>
               </a:rPr>
-              <a:t>12 / 15</a:t>
+              <a:t>12 / 16</a:t>
             </a:r>
             <a:endParaRPr lang="en-US" sz="1300" dirty="0"/>
           </a:p>
@@ -5311,7 +5400,7 @@
                 <a:ea typeface="Inter" pitchFamily="34" charset="-122"/>
                 <a:cs typeface="Inter" pitchFamily="34" charset="-120"/>
               </a:rPr>
-              <a:t>13 / 15</a:t>
+              <a:t>13 / 16</a:t>
             </a:r>
             <a:endParaRPr lang="en-US" sz="1300" dirty="0"/>
           </a:p>
@@ -6001,7 +6090,7 @@
                 <a:ea typeface="Inter" pitchFamily="34" charset="-122"/>
                 <a:cs typeface="Inter" pitchFamily="34" charset="-120"/>
               </a:rPr>
-              <a:t>14 / 15</a:t>
+              <a:t>14 / 16</a:t>
             </a:r>
             <a:endParaRPr lang="en-US" sz="1300" dirty="0"/>
           </a:p>
@@ -6056,7 +6145,7 @@
             </a:avLst>
           </a:prstGeom>
           <a:solidFill>
-            <a:srgbClr val="2196F3"/>
+            <a:srgbClr val="6F4CFF"/>
           </a:solidFill>
           <a:ln/>
         </p:spPr>
@@ -6112,13 +6201,13 @@
             <a:r>
               <a:rPr lang="en-US" sz="1400" b="1" spc="400" kern="0" dirty="0">
                 <a:solidFill>
-                  <a:srgbClr val="2196F3"/>
-                </a:solidFill>
-                <a:latin typeface="Inter" pitchFamily="34" charset="0"/>
-                <a:ea typeface="Inter" pitchFamily="34" charset="-122"/>
-                <a:cs typeface="Inter" pitchFamily="34" charset="-120"/>
-              </a:rPr>
-              <a:t>TIPS</a:t>
+                  <a:srgbClr val="6F4CFF"/>
+                </a:solidFill>
+                <a:latin typeface="Inter" pitchFamily="34" charset="0"/>
+                <a:ea typeface="Inter" pitchFamily="34" charset="-122"/>
+                <a:cs typeface="Inter" pitchFamily="34" charset="-120"/>
+              </a:rPr>
+              <a:t>DASHBOARD</a:t>
             </a:r>
             <a:endParaRPr lang="en-US" sz="1400" dirty="0"/>
           </a:p>
@@ -6157,7 +6246,7 @@
                 <a:ea typeface="Inter" pitchFamily="34" charset="-122"/>
                 <a:cs typeface="Inter" pitchFamily="34" charset="-120"/>
               </a:rPr>
-              <a:t>Tips · and if something breaks</a:t>
+              <a:t>A day with PhDapp</a:t>
             </a:r>
             <a:endParaRPr lang="en-US" sz="4000" dirty="0"/>
           </a:p>
@@ -6165,14 +6254,53 @@
       </p:sp>
       <p:sp>
         <p:nvSpPr>
-          <p:cNvPr id="6" name="Shape 3"/>
-          <p:cNvSpPr/>
-          <p:nvPr/>
-        </p:nvSpPr>
-        <p:spPr>
-          <a:xfrm>
-            <a:off x="548640" y="1828800"/>
-            <a:ext cx="5486400" cy="3931920"/>
+          <p:cNvPr id="6" name="Text 3"/>
+          <p:cNvSpPr/>
+          <p:nvPr/>
+        </p:nvSpPr>
+        <p:spPr>
+          <a:xfrm>
+            <a:off x="548640" y="1508760"/>
+            <a:ext cx="11094415" cy="822960"/>
+          </a:xfrm>
+          <a:prstGeom prst="rect">
+            <a:avLst/>
+          </a:prstGeom>
+          <a:noFill/>
+          <a:ln/>
+        </p:spPr>
+        <p:txBody>
+          <a:bodyPr wrap="square" lIns="0" tIns="0" rIns="0" bIns="0" rtlCol="0" anchor="t"/>
+          <a:lstStyle/>
+          <a:p>
+            <a:pPr indent="0" marL="0">
+              <a:buNone/>
+            </a:pPr>
+            <a:r>
+              <a:rPr lang="en-US" sz="2000" i="1" dirty="0">
+                <a:solidFill>
+                  <a:srgbClr val="334155"/>
+                </a:solidFill>
+                <a:latin typeface="Inter" pitchFamily="34" charset="0"/>
+                <a:ea typeface="Inter" pitchFamily="34" charset="-122"/>
+                <a:cs typeface="Inter" pitchFamily="34" charset="-120"/>
+              </a:rPr>
+              <a:t>Six moments a typical day — from morning standup to Friday wrap-up.</a:t>
+            </a:r>
+            <a:endParaRPr lang="en-US" sz="2000" dirty="0"/>
+          </a:p>
+        </p:txBody>
+      </p:sp>
+      <p:sp>
+        <p:nvSpPr>
+          <p:cNvPr id="7" name="Shape 4"/>
+          <p:cNvSpPr/>
+          <p:nvPr/>
+        </p:nvSpPr>
+        <p:spPr>
+          <a:xfrm>
+            <a:off x="548640" y="2286000"/>
+            <a:ext cx="3611880" cy="1783080"/>
           </a:xfrm>
           <a:prstGeom prst="rect">
             <a:avLst/>
@@ -6197,34 +6325,34 @@
       </p:sp>
       <p:sp>
         <p:nvSpPr>
-          <p:cNvPr id="7" name="Shape 4"/>
-          <p:cNvSpPr/>
-          <p:nvPr/>
-        </p:nvSpPr>
-        <p:spPr>
-          <a:xfrm>
-            <a:off x="548640" y="1828800"/>
-            <a:ext cx="73152" cy="3931920"/>
-          </a:xfrm>
-          <a:prstGeom prst="rect">
+          <p:cNvPr id="8" name="Shape 5"/>
+          <p:cNvSpPr/>
+          <p:nvPr/>
+        </p:nvSpPr>
+        <p:spPr>
+          <a:xfrm>
+            <a:off x="749808" y="2487168"/>
+            <a:ext cx="502920" cy="502920"/>
+          </a:xfrm>
+          <a:prstGeom prst="ellipse">
             <a:avLst/>
           </a:prstGeom>
           <a:solidFill>
-            <a:srgbClr val="2196F3"/>
+            <a:srgbClr val="6F4CFF"/>
           </a:solidFill>
           <a:ln/>
         </p:spPr>
       </p:sp>
       <p:sp>
         <p:nvSpPr>
-          <p:cNvPr id="8" name="Text 5"/>
-          <p:cNvSpPr/>
-          <p:nvPr/>
-        </p:nvSpPr>
-        <p:spPr>
-          <a:xfrm>
-            <a:off x="749808" y="1993392"/>
-            <a:ext cx="5166360" cy="594360"/>
+          <p:cNvPr id="9" name="Text 6"/>
+          <p:cNvSpPr/>
+          <p:nvPr/>
+        </p:nvSpPr>
+        <p:spPr>
+          <a:xfrm>
+            <a:off x="749808" y="2487168"/>
+            <a:ext cx="502920" cy="502920"/>
           </a:xfrm>
           <a:prstGeom prst="rect">
             <a:avLst/>
@@ -6236,6 +6364,45 @@
           <a:bodyPr wrap="square" lIns="0" tIns="0" rIns="0" bIns="0" rtlCol="0" anchor="ctr"/>
           <a:lstStyle/>
           <a:p>
+            <a:pPr algn="ctr" indent="0" marL="0">
+              <a:buNone/>
+            </a:pPr>
+            <a:r>
+              <a:rPr lang="en-US" sz="2200" b="1" dirty="0">
+                <a:solidFill>
+                  <a:srgbClr val="FFFFFF"/>
+                </a:solidFill>
+                <a:latin typeface="Inter" pitchFamily="34" charset="0"/>
+                <a:ea typeface="Inter" pitchFamily="34" charset="-122"/>
+                <a:cs typeface="Inter" pitchFamily="34" charset="-120"/>
+              </a:rPr>
+              <a:t>1</a:t>
+            </a:r>
+            <a:endParaRPr lang="en-US" sz="2200" dirty="0"/>
+          </a:p>
+        </p:txBody>
+      </p:sp>
+      <p:sp>
+        <p:nvSpPr>
+          <p:cNvPr id="10" name="Text 7"/>
+          <p:cNvSpPr/>
+          <p:nvPr/>
+        </p:nvSpPr>
+        <p:spPr>
+          <a:xfrm>
+            <a:off x="1417320" y="2532888"/>
+            <a:ext cx="2542032" cy="411480"/>
+          </a:xfrm>
+          <a:prstGeom prst="rect">
+            <a:avLst/>
+          </a:prstGeom>
+          <a:noFill/>
+          <a:ln/>
+        </p:spPr>
+        <p:txBody>
+          <a:bodyPr wrap="square" lIns="0" tIns="0" rIns="0" bIns="0" rtlCol="0" anchor="ctr"/>
+          <a:lstStyle/>
+          <a:p>
             <a:pPr indent="0" marL="0">
               <a:buNone/>
             </a:pPr>
@@ -6248,7 +6415,7 @@
                 <a:ea typeface="Inter" pitchFamily="34" charset="-122"/>
                 <a:cs typeface="Inter" pitchFamily="34" charset="-120"/>
               </a:rPr>
-              <a:t>Tips</a:t>
+              <a:t>Morning</a:t>
             </a:r>
             <a:endParaRPr lang="en-US" sz="2200" dirty="0"/>
           </a:p>
@@ -6256,14 +6423,14 @@
       </p:sp>
       <p:sp>
         <p:nvSpPr>
-          <p:cNvPr id="9" name="Text 6"/>
-          <p:cNvSpPr/>
-          <p:nvPr/>
-        </p:nvSpPr>
-        <p:spPr>
-          <a:xfrm>
-            <a:off x="777240" y="2697480"/>
-            <a:ext cx="5074920" cy="2926080"/>
+          <p:cNvPr id="11" name="Text 8"/>
+          <p:cNvSpPr/>
+          <p:nvPr/>
+        </p:nvSpPr>
+        <p:spPr>
+          <a:xfrm>
+            <a:off x="749808" y="3154680"/>
+            <a:ext cx="3246120" cy="777240"/>
           </a:xfrm>
           <a:prstGeom prst="rect">
             <a:avLst/>
@@ -6275,12 +6442,8 @@
           <a:bodyPr wrap="square" lIns="0" tIns="0" rIns="0" bIns="0" rtlCol="0" anchor="t"/>
           <a:lstStyle/>
           <a:p>
-            <a:pPr marL="342900" indent="-342900">
-              <a:spcAft>
-                <a:spcPts val="600"/>
-              </a:spcAft>
-              <a:buSzPct val="100000"/>
-              <a:buChar char="•"/>
+            <a:pPr indent="0" marL="0">
+              <a:buNone/>
             </a:pPr>
             <a:r>
               <a:rPr lang="en-US" sz="1800" dirty="0">
@@ -6291,106 +6454,22 @@
                 <a:ea typeface="Inter" pitchFamily="34" charset="-122"/>
                 <a:cs typeface="Inter" pitchFamily="34" charset="-120"/>
               </a:rPr>
-              <a:t>Keep the tab open — fewer missed alerts.</a:t>
+              <a:t>Open Dashboard — Due this week + next 7 days.</a:t>
             </a:r>
             <a:endParaRPr lang="en-US" sz="1800" dirty="0"/>
           </a:p>
-          <a:p>
-            <a:pPr marL="342900" indent="-342900">
-              <a:spcAft>
-                <a:spcPts val="600"/>
-              </a:spcAft>
-              <a:buSzPct val="100000"/>
-              <a:buChar char="•"/>
-            </a:pPr>
-            <a:r>
-              <a:rPr lang="en-US" sz="1800" dirty="0">
-                <a:solidFill>
-                  <a:srgbClr val="334155"/>
-                </a:solidFill>
-                <a:latin typeface="Inter" pitchFamily="34" charset="0"/>
-                <a:ea typeface="Inter" pitchFamily="34" charset="-122"/>
-                <a:cs typeface="Inter" pitchFamily="34" charset="-120"/>
-              </a:rPr>
-              <a:t>Channels for back-and-forth; comments for tasks.</a:t>
-            </a:r>
-            <a:endParaRPr lang="en-US" sz="1800" dirty="0"/>
-          </a:p>
-          <a:p>
-            <a:pPr marL="342900" indent="-342900">
-              <a:spcAft>
-                <a:spcPts val="600"/>
-              </a:spcAft>
-              <a:buSzPct val="100000"/>
-              <a:buChar char="•"/>
-            </a:pPr>
-            <a:r>
-              <a:rPr lang="en-US" sz="1800" dirty="0">
-                <a:solidFill>
-                  <a:srgbClr val="334155"/>
-                </a:solidFill>
-                <a:latin typeface="Inter" pitchFamily="34" charset="0"/>
-                <a:ea typeface="Inter" pitchFamily="34" charset="-122"/>
-                <a:cs typeface="Inter" pitchFamily="34" charset="-120"/>
-              </a:rPr>
-              <a:t>Tag tasks with priority + due date.</a:t>
-            </a:r>
-            <a:endParaRPr lang="en-US" sz="1800" dirty="0"/>
-          </a:p>
-          <a:p>
-            <a:pPr marL="342900" indent="-342900">
-              <a:spcAft>
-                <a:spcPts val="600"/>
-              </a:spcAft>
-              <a:buSzPct val="100000"/>
-              <a:buChar char="•"/>
-            </a:pPr>
-            <a:r>
-              <a:rPr lang="en-US" sz="1800" dirty="0">
-                <a:solidFill>
-                  <a:srgbClr val="334155"/>
-                </a:solidFill>
-                <a:latin typeface="Inter" pitchFamily="34" charset="0"/>
-                <a:ea typeface="Inter" pitchFamily="34" charset="-122"/>
-                <a:cs typeface="Inter" pitchFamily="34" charset="-120"/>
-              </a:rPr>
-              <a:t>Drop a weekly check-in even if quiet.</a:t>
-            </a:r>
-            <a:endParaRPr lang="en-US" sz="1800" dirty="0"/>
-          </a:p>
-          <a:p>
-            <a:pPr marL="342900" indent="-342900">
-              <a:spcAft>
-                <a:spcPts val="600"/>
-              </a:spcAft>
-              <a:buSzPct val="100000"/>
-              <a:buChar char="•"/>
-            </a:pPr>
-            <a:r>
-              <a:rPr lang="en-US" sz="1800" dirty="0">
-                <a:solidFill>
-                  <a:srgbClr val="334155"/>
-                </a:solidFill>
-                <a:latin typeface="Inter" pitchFamily="34" charset="0"/>
-                <a:ea typeface="Inter" pitchFamily="34" charset="-122"/>
-                <a:cs typeface="Inter" pitchFamily="34" charset="-120"/>
-              </a:rPr>
-              <a:t>Right-click events → add to your iCal / Calendar.</a:t>
-            </a:r>
-            <a:endParaRPr lang="en-US" sz="1800" dirty="0"/>
-          </a:p>
-        </p:txBody>
-      </p:sp>
-      <p:sp>
-        <p:nvSpPr>
-          <p:cNvPr id="10" name="Shape 7"/>
-          <p:cNvSpPr/>
-          <p:nvPr/>
-        </p:nvSpPr>
-        <p:spPr>
-          <a:xfrm>
-            <a:off x="6400800" y="1828800"/>
-            <a:ext cx="5242255" cy="3931920"/>
+        </p:txBody>
+      </p:sp>
+      <p:sp>
+        <p:nvSpPr>
+          <p:cNvPr id="12" name="Shape 9"/>
+          <p:cNvSpPr/>
+          <p:nvPr/>
+        </p:nvSpPr>
+        <p:spPr>
+          <a:xfrm>
+            <a:off x="4343400" y="2286000"/>
+            <a:ext cx="3611880" cy="1783080"/>
           </a:xfrm>
           <a:prstGeom prst="rect">
             <a:avLst/>
@@ -6415,34 +6494,1136 @@
       </p:sp>
       <p:sp>
         <p:nvSpPr>
-          <p:cNvPr id="11" name="Shape 8"/>
-          <p:cNvSpPr/>
-          <p:nvPr/>
-        </p:nvSpPr>
-        <p:spPr>
-          <a:xfrm>
-            <a:off x="6400800" y="1828800"/>
+          <p:cNvPr id="13" name="Shape 10"/>
+          <p:cNvSpPr/>
+          <p:nvPr/>
+        </p:nvSpPr>
+        <p:spPr>
+          <a:xfrm>
+            <a:off x="4544568" y="2487168"/>
+            <a:ext cx="502920" cy="502920"/>
+          </a:xfrm>
+          <a:prstGeom prst="ellipse">
+            <a:avLst/>
+          </a:prstGeom>
+          <a:solidFill>
+            <a:srgbClr val="FF3D8B"/>
+          </a:solidFill>
+          <a:ln/>
+        </p:spPr>
+      </p:sp>
+      <p:sp>
+        <p:nvSpPr>
+          <p:cNvPr id="14" name="Text 11"/>
+          <p:cNvSpPr/>
+          <p:nvPr/>
+        </p:nvSpPr>
+        <p:spPr>
+          <a:xfrm>
+            <a:off x="4544568" y="2487168"/>
+            <a:ext cx="502920" cy="502920"/>
+          </a:xfrm>
+          <a:prstGeom prst="rect">
+            <a:avLst/>
+          </a:prstGeom>
+          <a:noFill/>
+          <a:ln/>
+        </p:spPr>
+        <p:txBody>
+          <a:bodyPr wrap="square" lIns="0" tIns="0" rIns="0" bIns="0" rtlCol="0" anchor="ctr"/>
+          <a:lstStyle/>
+          <a:p>
+            <a:pPr algn="ctr" indent="0" marL="0">
+              <a:buNone/>
+            </a:pPr>
+            <a:r>
+              <a:rPr lang="en-US" sz="2200" b="1" dirty="0">
+                <a:solidFill>
+                  <a:srgbClr val="FFFFFF"/>
+                </a:solidFill>
+                <a:latin typeface="Inter" pitchFamily="34" charset="0"/>
+                <a:ea typeface="Inter" pitchFamily="34" charset="-122"/>
+                <a:cs typeface="Inter" pitchFamily="34" charset="-120"/>
+              </a:rPr>
+              <a:t>2</a:t>
+            </a:r>
+            <a:endParaRPr lang="en-US" sz="2200" dirty="0"/>
+          </a:p>
+        </p:txBody>
+      </p:sp>
+      <p:sp>
+        <p:nvSpPr>
+          <p:cNvPr id="15" name="Text 12"/>
+          <p:cNvSpPr/>
+          <p:nvPr/>
+        </p:nvSpPr>
+        <p:spPr>
+          <a:xfrm>
+            <a:off x="5212080" y="2532888"/>
+            <a:ext cx="2542032" cy="411480"/>
+          </a:xfrm>
+          <a:prstGeom prst="rect">
+            <a:avLst/>
+          </a:prstGeom>
+          <a:noFill/>
+          <a:ln/>
+        </p:spPr>
+        <p:txBody>
+          <a:bodyPr wrap="square" lIns="0" tIns="0" rIns="0" bIns="0" rtlCol="0" anchor="ctr"/>
+          <a:lstStyle/>
+          <a:p>
+            <a:pPr indent="0" marL="0">
+              <a:buNone/>
+            </a:pPr>
+            <a:r>
+              <a:rPr lang="en-US" sz="2200" b="1" dirty="0">
+                <a:solidFill>
+                  <a:srgbClr val="0F172A"/>
+                </a:solidFill>
+                <a:latin typeface="Inter" pitchFamily="34" charset="0"/>
+                <a:ea typeface="Inter" pitchFamily="34" charset="-122"/>
+                <a:cs typeface="Inter" pitchFamily="34" charset="-120"/>
+              </a:rPr>
+              <a:t>🔔 Bell</a:t>
+            </a:r>
+            <a:endParaRPr lang="en-US" sz="2200" dirty="0"/>
+          </a:p>
+        </p:txBody>
+      </p:sp>
+      <p:sp>
+        <p:nvSpPr>
+          <p:cNvPr id="16" name="Text 13"/>
+          <p:cNvSpPr/>
+          <p:nvPr/>
+        </p:nvSpPr>
+        <p:spPr>
+          <a:xfrm>
+            <a:off x="4544568" y="3154680"/>
+            <a:ext cx="3246120" cy="777240"/>
+          </a:xfrm>
+          <a:prstGeom prst="rect">
+            <a:avLst/>
+          </a:prstGeom>
+          <a:noFill/>
+          <a:ln/>
+        </p:spPr>
+        <p:txBody>
+          <a:bodyPr wrap="square" lIns="0" tIns="0" rIns="0" bIns="0" rtlCol="0" anchor="t"/>
+          <a:lstStyle/>
+          <a:p>
+            <a:pPr indent="0" marL="0">
+              <a:buNone/>
+            </a:pPr>
+            <a:r>
+              <a:rPr lang="en-US" sz="1800" dirty="0">
+                <a:solidFill>
+                  <a:srgbClr val="334155"/>
+                </a:solidFill>
+                <a:latin typeface="Inter" pitchFamily="34" charset="0"/>
+                <a:ea typeface="Inter" pitchFamily="34" charset="-122"/>
+                <a:cs typeface="Inter" pitchFamily="34" charset="-120"/>
+              </a:rPr>
+              <a:t>Skim what supervisors changed since yesterday.</a:t>
+            </a:r>
+            <a:endParaRPr lang="en-US" sz="1800" dirty="0"/>
+          </a:p>
+        </p:txBody>
+      </p:sp>
+      <p:sp>
+        <p:nvSpPr>
+          <p:cNvPr id="17" name="Shape 14"/>
+          <p:cNvSpPr/>
+          <p:nvPr/>
+        </p:nvSpPr>
+        <p:spPr>
+          <a:xfrm>
+            <a:off x="8138160" y="2286000"/>
+            <a:ext cx="3611880" cy="1783080"/>
+          </a:xfrm>
+          <a:prstGeom prst="rect">
+            <a:avLst/>
+          </a:prstGeom>
+          <a:solidFill>
+            <a:srgbClr val="FFFFFF"/>
+          </a:solidFill>
+          <a:ln w="9525">
+            <a:solidFill>
+              <a:srgbClr val="E2E8F0"/>
+            </a:solidFill>
+            <a:prstDash val="solid"/>
+          </a:ln>
+          <a:effectLst>
+            <a:outerShdw sx="100000" sy="100000" kx="0" ky="0" algn="bl" rotWithShape="0" blurRad="76200" dist="12700" dir="5400000">
+              <a:srgbClr val="94A3B8">
+                <a:alpha val="12000"/>
+              </a:srgbClr>
+            </a:outerShdw>
+          </a:effectLst>
+        </p:spPr>
+      </p:sp>
+      <p:sp>
+        <p:nvSpPr>
+          <p:cNvPr id="18" name="Shape 15"/>
+          <p:cNvSpPr/>
+          <p:nvPr/>
+        </p:nvSpPr>
+        <p:spPr>
+          <a:xfrm>
+            <a:off x="8339328" y="2487168"/>
+            <a:ext cx="502920" cy="502920"/>
+          </a:xfrm>
+          <a:prstGeom prst="ellipse">
+            <a:avLst/>
+          </a:prstGeom>
+          <a:solidFill>
+            <a:srgbClr val="FF7A45"/>
+          </a:solidFill>
+          <a:ln/>
+        </p:spPr>
+      </p:sp>
+      <p:sp>
+        <p:nvSpPr>
+          <p:cNvPr id="19" name="Text 16"/>
+          <p:cNvSpPr/>
+          <p:nvPr/>
+        </p:nvSpPr>
+        <p:spPr>
+          <a:xfrm>
+            <a:off x="8339328" y="2487168"/>
+            <a:ext cx="502920" cy="502920"/>
+          </a:xfrm>
+          <a:prstGeom prst="rect">
+            <a:avLst/>
+          </a:prstGeom>
+          <a:noFill/>
+          <a:ln/>
+        </p:spPr>
+        <p:txBody>
+          <a:bodyPr wrap="square" lIns="0" tIns="0" rIns="0" bIns="0" rtlCol="0" anchor="ctr"/>
+          <a:lstStyle/>
+          <a:p>
+            <a:pPr algn="ctr" indent="0" marL="0">
+              <a:buNone/>
+            </a:pPr>
+            <a:r>
+              <a:rPr lang="en-US" sz="2200" b="1" dirty="0">
+                <a:solidFill>
+                  <a:srgbClr val="FFFFFF"/>
+                </a:solidFill>
+                <a:latin typeface="Inter" pitchFamily="34" charset="0"/>
+                <a:ea typeface="Inter" pitchFamily="34" charset="-122"/>
+                <a:cs typeface="Inter" pitchFamily="34" charset="-120"/>
+              </a:rPr>
+              <a:t>3</a:t>
+            </a:r>
+            <a:endParaRPr lang="en-US" sz="2200" dirty="0"/>
+          </a:p>
+        </p:txBody>
+      </p:sp>
+      <p:sp>
+        <p:nvSpPr>
+          <p:cNvPr id="20" name="Text 17"/>
+          <p:cNvSpPr/>
+          <p:nvPr/>
+        </p:nvSpPr>
+        <p:spPr>
+          <a:xfrm>
+            <a:off x="9006840" y="2532888"/>
+            <a:ext cx="2542032" cy="411480"/>
+          </a:xfrm>
+          <a:prstGeom prst="rect">
+            <a:avLst/>
+          </a:prstGeom>
+          <a:noFill/>
+          <a:ln/>
+        </p:spPr>
+        <p:txBody>
+          <a:bodyPr wrap="square" lIns="0" tIns="0" rIns="0" bIns="0" rtlCol="0" anchor="ctr"/>
+          <a:lstStyle/>
+          <a:p>
+            <a:pPr indent="0" marL="0">
+              <a:buNone/>
+            </a:pPr>
+            <a:r>
+              <a:rPr lang="en-US" sz="2200" b="1" dirty="0">
+                <a:solidFill>
+                  <a:srgbClr val="0F172A"/>
+                </a:solidFill>
+                <a:latin typeface="Inter" pitchFamily="34" charset="0"/>
+                <a:ea typeface="Inter" pitchFamily="34" charset="-122"/>
+                <a:cs typeface="Inter" pitchFamily="34" charset="-120"/>
+              </a:rPr>
+              <a:t>Tasks</a:t>
+            </a:r>
+            <a:endParaRPr lang="en-US" sz="2200" dirty="0"/>
+          </a:p>
+        </p:txBody>
+      </p:sp>
+      <p:sp>
+        <p:nvSpPr>
+          <p:cNvPr id="21" name="Text 18"/>
+          <p:cNvSpPr/>
+          <p:nvPr/>
+        </p:nvSpPr>
+        <p:spPr>
+          <a:xfrm>
+            <a:off x="8339328" y="3154680"/>
+            <a:ext cx="3246120" cy="777240"/>
+          </a:xfrm>
+          <a:prstGeom prst="rect">
+            <a:avLst/>
+          </a:prstGeom>
+          <a:noFill/>
+          <a:ln/>
+        </p:spPr>
+        <p:txBody>
+          <a:bodyPr wrap="square" lIns="0" tIns="0" rIns="0" bIns="0" rtlCol="0" anchor="t"/>
+          <a:lstStyle/>
+          <a:p>
+            <a:pPr indent="0" marL="0">
+              <a:buNone/>
+            </a:pPr>
+            <a:r>
+              <a:rPr lang="en-US" sz="1800" dirty="0">
+                <a:solidFill>
+                  <a:srgbClr val="334155"/>
+                </a:solidFill>
+                <a:latin typeface="Inter" pitchFamily="34" charset="0"/>
+                <a:ea typeface="Inter" pitchFamily="34" charset="-122"/>
+                <a:cs typeface="Inter" pitchFamily="34" charset="-120"/>
+              </a:rPr>
+              <a:t>Drag through statuses; Mark as completed when done.</a:t>
+            </a:r>
+            <a:endParaRPr lang="en-US" sz="1800" dirty="0"/>
+          </a:p>
+        </p:txBody>
+      </p:sp>
+      <p:sp>
+        <p:nvSpPr>
+          <p:cNvPr id="22" name="Shape 19"/>
+          <p:cNvSpPr/>
+          <p:nvPr/>
+        </p:nvSpPr>
+        <p:spPr>
+          <a:xfrm>
+            <a:off x="548640" y="4297680"/>
+            <a:ext cx="3611880" cy="1783080"/>
+          </a:xfrm>
+          <a:prstGeom prst="rect">
+            <a:avLst/>
+          </a:prstGeom>
+          <a:solidFill>
+            <a:srgbClr val="FFFFFF"/>
+          </a:solidFill>
+          <a:ln w="9525">
+            <a:solidFill>
+              <a:srgbClr val="E2E8F0"/>
+            </a:solidFill>
+            <a:prstDash val="solid"/>
+          </a:ln>
+          <a:effectLst>
+            <a:outerShdw sx="100000" sy="100000" kx="0" ky="0" algn="bl" rotWithShape="0" blurRad="76200" dist="12700" dir="5400000">
+              <a:srgbClr val="94A3B8">
+                <a:alpha val="12000"/>
+              </a:srgbClr>
+            </a:outerShdw>
+          </a:effectLst>
+        </p:spPr>
+      </p:sp>
+      <p:sp>
+        <p:nvSpPr>
+          <p:cNvPr id="23" name="Shape 20"/>
+          <p:cNvSpPr/>
+          <p:nvPr/>
+        </p:nvSpPr>
+        <p:spPr>
+          <a:xfrm>
+            <a:off x="749808" y="4498848"/>
+            <a:ext cx="502920" cy="502920"/>
+          </a:xfrm>
+          <a:prstGeom prst="ellipse">
+            <a:avLst/>
+          </a:prstGeom>
+          <a:solidFill>
+            <a:srgbClr val="00D1C1"/>
+          </a:solidFill>
+          <a:ln/>
+        </p:spPr>
+      </p:sp>
+      <p:sp>
+        <p:nvSpPr>
+          <p:cNvPr id="24" name="Text 21"/>
+          <p:cNvSpPr/>
+          <p:nvPr/>
+        </p:nvSpPr>
+        <p:spPr>
+          <a:xfrm>
+            <a:off x="749808" y="4498848"/>
+            <a:ext cx="502920" cy="502920"/>
+          </a:xfrm>
+          <a:prstGeom prst="rect">
+            <a:avLst/>
+          </a:prstGeom>
+          <a:noFill/>
+          <a:ln/>
+        </p:spPr>
+        <p:txBody>
+          <a:bodyPr wrap="square" lIns="0" tIns="0" rIns="0" bIns="0" rtlCol="0" anchor="ctr"/>
+          <a:lstStyle/>
+          <a:p>
+            <a:pPr algn="ctr" indent="0" marL="0">
+              <a:buNone/>
+            </a:pPr>
+            <a:r>
+              <a:rPr lang="en-US" sz="2200" b="1" dirty="0">
+                <a:solidFill>
+                  <a:srgbClr val="FFFFFF"/>
+                </a:solidFill>
+                <a:latin typeface="Inter" pitchFamily="34" charset="0"/>
+                <a:ea typeface="Inter" pitchFamily="34" charset="-122"/>
+                <a:cs typeface="Inter" pitchFamily="34" charset="-120"/>
+              </a:rPr>
+              <a:t>4</a:t>
+            </a:r>
+            <a:endParaRPr lang="en-US" sz="2200" dirty="0"/>
+          </a:p>
+        </p:txBody>
+      </p:sp>
+      <p:sp>
+        <p:nvSpPr>
+          <p:cNvPr id="25" name="Text 22"/>
+          <p:cNvSpPr/>
+          <p:nvPr/>
+        </p:nvSpPr>
+        <p:spPr>
+          <a:xfrm>
+            <a:off x="1417320" y="4544568"/>
+            <a:ext cx="2542032" cy="411480"/>
+          </a:xfrm>
+          <a:prstGeom prst="rect">
+            <a:avLst/>
+          </a:prstGeom>
+          <a:noFill/>
+          <a:ln/>
+        </p:spPr>
+        <p:txBody>
+          <a:bodyPr wrap="square" lIns="0" tIns="0" rIns="0" bIns="0" rtlCol="0" anchor="ctr"/>
+          <a:lstStyle/>
+          <a:p>
+            <a:pPr indent="0" marL="0">
+              <a:buNone/>
+            </a:pPr>
+            <a:r>
+              <a:rPr lang="en-US" sz="2200" b="1" dirty="0">
+                <a:solidFill>
+                  <a:srgbClr val="0F172A"/>
+                </a:solidFill>
+                <a:latin typeface="Inter" pitchFamily="34" charset="0"/>
+                <a:ea typeface="Inter" pitchFamily="34" charset="-122"/>
+                <a:cs typeface="Inter" pitchFamily="34" charset="-120"/>
+              </a:rPr>
+              <a:t>Meetings</a:t>
+            </a:r>
+            <a:endParaRPr lang="en-US" sz="2200" dirty="0"/>
+          </a:p>
+        </p:txBody>
+      </p:sp>
+      <p:sp>
+        <p:nvSpPr>
+          <p:cNvPr id="26" name="Text 23"/>
+          <p:cNvSpPr/>
+          <p:nvPr/>
+        </p:nvSpPr>
+        <p:spPr>
+          <a:xfrm>
+            <a:off x="749808" y="5166360"/>
+            <a:ext cx="3246120" cy="777240"/>
+          </a:xfrm>
+          <a:prstGeom prst="rect">
+            <a:avLst/>
+          </a:prstGeom>
+          <a:noFill/>
+          <a:ln/>
+        </p:spPr>
+        <p:txBody>
+          <a:bodyPr wrap="square" lIns="0" tIns="0" rIns="0" bIns="0" rtlCol="0" anchor="t"/>
+          <a:lstStyle/>
+          <a:p>
+            <a:pPr indent="0" marL="0">
+              <a:buNone/>
+            </a:pPr>
+            <a:r>
+              <a:rPr lang="en-US" sz="1800" dirty="0">
+                <a:solidFill>
+                  <a:srgbClr val="334155"/>
+                </a:solidFill>
+                <a:latin typeface="Inter" pitchFamily="34" charset="0"/>
+                <a:ea typeface="Inter" pitchFamily="34" charset="-122"/>
+                <a:cs typeface="Inter" pitchFamily="34" charset="-120"/>
+              </a:rPr>
+              <a:t>Open Calendar — today's 1:1s; add agenda points.</a:t>
+            </a:r>
+            <a:endParaRPr lang="en-US" sz="1800" dirty="0"/>
+          </a:p>
+        </p:txBody>
+      </p:sp>
+      <p:sp>
+        <p:nvSpPr>
+          <p:cNvPr id="27" name="Shape 24"/>
+          <p:cNvSpPr/>
+          <p:nvPr/>
+        </p:nvSpPr>
+        <p:spPr>
+          <a:xfrm>
+            <a:off x="4343400" y="4297680"/>
+            <a:ext cx="3611880" cy="1783080"/>
+          </a:xfrm>
+          <a:prstGeom prst="rect">
+            <a:avLst/>
+          </a:prstGeom>
+          <a:solidFill>
+            <a:srgbClr val="FFFFFF"/>
+          </a:solidFill>
+          <a:ln w="9525">
+            <a:solidFill>
+              <a:srgbClr val="E2E8F0"/>
+            </a:solidFill>
+            <a:prstDash val="solid"/>
+          </a:ln>
+          <a:effectLst>
+            <a:outerShdw sx="100000" sy="100000" kx="0" ky="0" algn="bl" rotWithShape="0" blurRad="76200" dist="12700" dir="5400000">
+              <a:srgbClr val="94A3B8">
+                <a:alpha val="12000"/>
+              </a:srgbClr>
+            </a:outerShdw>
+          </a:effectLst>
+        </p:spPr>
+      </p:sp>
+      <p:sp>
+        <p:nvSpPr>
+          <p:cNvPr id="28" name="Shape 25"/>
+          <p:cNvSpPr/>
+          <p:nvPr/>
+        </p:nvSpPr>
+        <p:spPr>
+          <a:xfrm>
+            <a:off x="4544568" y="4498848"/>
+            <a:ext cx="502920" cy="502920"/>
+          </a:xfrm>
+          <a:prstGeom prst="ellipse">
+            <a:avLst/>
+          </a:prstGeom>
+          <a:solidFill>
+            <a:srgbClr val="00CA72"/>
+          </a:solidFill>
+          <a:ln/>
+        </p:spPr>
+      </p:sp>
+      <p:sp>
+        <p:nvSpPr>
+          <p:cNvPr id="29" name="Text 26"/>
+          <p:cNvSpPr/>
+          <p:nvPr/>
+        </p:nvSpPr>
+        <p:spPr>
+          <a:xfrm>
+            <a:off x="4544568" y="4498848"/>
+            <a:ext cx="502920" cy="502920"/>
+          </a:xfrm>
+          <a:prstGeom prst="rect">
+            <a:avLst/>
+          </a:prstGeom>
+          <a:noFill/>
+          <a:ln/>
+        </p:spPr>
+        <p:txBody>
+          <a:bodyPr wrap="square" lIns="0" tIns="0" rIns="0" bIns="0" rtlCol="0" anchor="ctr"/>
+          <a:lstStyle/>
+          <a:p>
+            <a:pPr algn="ctr" indent="0" marL="0">
+              <a:buNone/>
+            </a:pPr>
+            <a:r>
+              <a:rPr lang="en-US" sz="2200" b="1" dirty="0">
+                <a:solidFill>
+                  <a:srgbClr val="FFFFFF"/>
+                </a:solidFill>
+                <a:latin typeface="Inter" pitchFamily="34" charset="0"/>
+                <a:ea typeface="Inter" pitchFamily="34" charset="-122"/>
+                <a:cs typeface="Inter" pitchFamily="34" charset="-120"/>
+              </a:rPr>
+              <a:t>5</a:t>
+            </a:r>
+            <a:endParaRPr lang="en-US" sz="2200" dirty="0"/>
+          </a:p>
+        </p:txBody>
+      </p:sp>
+      <p:sp>
+        <p:nvSpPr>
+          <p:cNvPr id="30" name="Text 27"/>
+          <p:cNvSpPr/>
+          <p:nvPr/>
+        </p:nvSpPr>
+        <p:spPr>
+          <a:xfrm>
+            <a:off x="5212080" y="4544568"/>
+            <a:ext cx="2542032" cy="411480"/>
+          </a:xfrm>
+          <a:prstGeom prst="rect">
+            <a:avLst/>
+          </a:prstGeom>
+          <a:noFill/>
+          <a:ln/>
+        </p:spPr>
+        <p:txBody>
+          <a:bodyPr wrap="square" lIns="0" tIns="0" rIns="0" bIns="0" rtlCol="0" anchor="ctr"/>
+          <a:lstStyle/>
+          <a:p>
+            <a:pPr indent="0" marL="0">
+              <a:buNone/>
+            </a:pPr>
+            <a:r>
+              <a:rPr lang="en-US" sz="2200" b="1" dirty="0">
+                <a:solidFill>
+                  <a:srgbClr val="0F172A"/>
+                </a:solidFill>
+                <a:latin typeface="Inter" pitchFamily="34" charset="0"/>
+                <a:ea typeface="Inter" pitchFamily="34" charset="-122"/>
+                <a:cs typeface="Inter" pitchFamily="34" charset="-120"/>
+              </a:rPr>
+              <a:t>Chat &amp; files</a:t>
+            </a:r>
+            <a:endParaRPr lang="en-US" sz="2200" dirty="0"/>
+          </a:p>
+        </p:txBody>
+      </p:sp>
+      <p:sp>
+        <p:nvSpPr>
+          <p:cNvPr id="31" name="Text 28"/>
+          <p:cNvSpPr/>
+          <p:nvPr/>
+        </p:nvSpPr>
+        <p:spPr>
+          <a:xfrm>
+            <a:off x="4544568" y="5166360"/>
+            <a:ext cx="3246120" cy="777240"/>
+          </a:xfrm>
+          <a:prstGeom prst="rect">
+            <a:avLst/>
+          </a:prstGeom>
+          <a:noFill/>
+          <a:ln/>
+        </p:spPr>
+        <p:txBody>
+          <a:bodyPr wrap="square" lIns="0" tIns="0" rIns="0" bIns="0" rtlCol="0" anchor="t"/>
+          <a:lstStyle/>
+          <a:p>
+            <a:pPr indent="0" marL="0">
+              <a:buNone/>
+            </a:pPr>
+            <a:r>
+              <a:rPr lang="en-US" sz="1800" dirty="0">
+                <a:solidFill>
+                  <a:srgbClr val="334155"/>
+                </a:solidFill>
+                <a:latin typeface="Inter" pitchFamily="34" charset="0"/>
+                <a:ea typeface="Inter" pitchFamily="34" charset="-122"/>
+                <a:cs typeface="Inter" pitchFamily="34" charset="-120"/>
+              </a:rPr>
+              <a:t>Reply in your Team channel; drag files, ⌘V screenshots.</a:t>
+            </a:r>
+            <a:endParaRPr lang="en-US" sz="1800" dirty="0"/>
+          </a:p>
+        </p:txBody>
+      </p:sp>
+      <p:sp>
+        <p:nvSpPr>
+          <p:cNvPr id="32" name="Shape 29"/>
+          <p:cNvSpPr/>
+          <p:nvPr/>
+        </p:nvSpPr>
+        <p:spPr>
+          <a:xfrm>
+            <a:off x="8138160" y="4297680"/>
+            <a:ext cx="3611880" cy="1783080"/>
+          </a:xfrm>
+          <a:prstGeom prst="rect">
+            <a:avLst/>
+          </a:prstGeom>
+          <a:solidFill>
+            <a:srgbClr val="FFFFFF"/>
+          </a:solidFill>
+          <a:ln w="9525">
+            <a:solidFill>
+              <a:srgbClr val="E2E8F0"/>
+            </a:solidFill>
+            <a:prstDash val="solid"/>
+          </a:ln>
+          <a:effectLst>
+            <a:outerShdw sx="100000" sy="100000" kx="0" ky="0" algn="bl" rotWithShape="0" blurRad="76200" dist="12700" dir="5400000">
+              <a:srgbClr val="94A3B8">
+                <a:alpha val="12000"/>
+              </a:srgbClr>
+            </a:outerShdw>
+          </a:effectLst>
+        </p:spPr>
+      </p:sp>
+      <p:sp>
+        <p:nvSpPr>
+          <p:cNvPr id="33" name="Shape 30"/>
+          <p:cNvSpPr/>
+          <p:nvPr/>
+        </p:nvSpPr>
+        <p:spPr>
+          <a:xfrm>
+            <a:off x="8339328" y="4498848"/>
+            <a:ext cx="502920" cy="502920"/>
+          </a:xfrm>
+          <a:prstGeom prst="ellipse">
+            <a:avLst/>
+          </a:prstGeom>
+          <a:solidFill>
+            <a:srgbClr val="6F4CFF"/>
+          </a:solidFill>
+          <a:ln/>
+        </p:spPr>
+      </p:sp>
+      <p:sp>
+        <p:nvSpPr>
+          <p:cNvPr id="34" name="Text 31"/>
+          <p:cNvSpPr/>
+          <p:nvPr/>
+        </p:nvSpPr>
+        <p:spPr>
+          <a:xfrm>
+            <a:off x="8339328" y="4498848"/>
+            <a:ext cx="502920" cy="502920"/>
+          </a:xfrm>
+          <a:prstGeom prst="rect">
+            <a:avLst/>
+          </a:prstGeom>
+          <a:noFill/>
+          <a:ln/>
+        </p:spPr>
+        <p:txBody>
+          <a:bodyPr wrap="square" lIns="0" tIns="0" rIns="0" bIns="0" rtlCol="0" anchor="ctr"/>
+          <a:lstStyle/>
+          <a:p>
+            <a:pPr algn="ctr" indent="0" marL="0">
+              <a:buNone/>
+            </a:pPr>
+            <a:r>
+              <a:rPr lang="en-US" sz="2200" b="1" dirty="0">
+                <a:solidFill>
+                  <a:srgbClr val="FFFFFF"/>
+                </a:solidFill>
+                <a:latin typeface="Inter" pitchFamily="34" charset="0"/>
+                <a:ea typeface="Inter" pitchFamily="34" charset="-122"/>
+                <a:cs typeface="Inter" pitchFamily="34" charset="-120"/>
+              </a:rPr>
+              <a:t>6</a:t>
+            </a:r>
+            <a:endParaRPr lang="en-US" sz="2200" dirty="0"/>
+          </a:p>
+        </p:txBody>
+      </p:sp>
+      <p:sp>
+        <p:nvSpPr>
+          <p:cNvPr id="35" name="Text 32"/>
+          <p:cNvSpPr/>
+          <p:nvPr/>
+        </p:nvSpPr>
+        <p:spPr>
+          <a:xfrm>
+            <a:off x="9006840" y="4544568"/>
+            <a:ext cx="2542032" cy="411480"/>
+          </a:xfrm>
+          <a:prstGeom prst="rect">
+            <a:avLst/>
+          </a:prstGeom>
+          <a:noFill/>
+          <a:ln/>
+        </p:spPr>
+        <p:txBody>
+          <a:bodyPr wrap="square" lIns="0" tIns="0" rIns="0" bIns="0" rtlCol="0" anchor="ctr"/>
+          <a:lstStyle/>
+          <a:p>
+            <a:pPr indent="0" marL="0">
+              <a:buNone/>
+            </a:pPr>
+            <a:r>
+              <a:rPr lang="en-US" sz="2200" b="1" dirty="0">
+                <a:solidFill>
+                  <a:srgbClr val="0F172A"/>
+                </a:solidFill>
+                <a:latin typeface="Inter" pitchFamily="34" charset="0"/>
+                <a:ea typeface="Inter" pitchFamily="34" charset="-122"/>
+                <a:cs typeface="Inter" pitchFamily="34" charset="-120"/>
+              </a:rPr>
+              <a:t>Friday</a:t>
+            </a:r>
+            <a:endParaRPr lang="en-US" sz="2200" dirty="0"/>
+          </a:p>
+        </p:txBody>
+      </p:sp>
+      <p:sp>
+        <p:nvSpPr>
+          <p:cNvPr id="36" name="Text 33"/>
+          <p:cNvSpPr/>
+          <p:nvPr/>
+        </p:nvSpPr>
+        <p:spPr>
+          <a:xfrm>
+            <a:off x="8339328" y="5166360"/>
+            <a:ext cx="3246120" cy="777240"/>
+          </a:xfrm>
+          <a:prstGeom prst="rect">
+            <a:avLst/>
+          </a:prstGeom>
+          <a:noFill/>
+          <a:ln/>
+        </p:spPr>
+        <p:txBody>
+          <a:bodyPr wrap="square" lIns="0" tIns="0" rIns="0" bIns="0" rtlCol="0" anchor="t"/>
+          <a:lstStyle/>
+          <a:p>
+            <a:pPr indent="0" marL="0">
+              <a:buNone/>
+            </a:pPr>
+            <a:r>
+              <a:rPr lang="en-US" sz="1800" dirty="0">
+                <a:solidFill>
+                  <a:srgbClr val="334155"/>
+                </a:solidFill>
+                <a:latin typeface="Inter" pitchFamily="34" charset="0"/>
+                <a:ea typeface="Inter" pitchFamily="34" charset="-122"/>
+                <a:cs typeface="Inter" pitchFamily="34" charset="-120"/>
+              </a:rPr>
+              <a:t>Weekly check-in — Did / Blockers / Next + wellbeing.</a:t>
+            </a:r>
+            <a:endParaRPr lang="en-US" sz="1800" dirty="0"/>
+          </a:p>
+        </p:txBody>
+      </p:sp>
+      <p:sp>
+        <p:nvSpPr>
+          <p:cNvPr id="37" name="Shape 34"/>
+          <p:cNvSpPr/>
+          <p:nvPr/>
+        </p:nvSpPr>
+        <p:spPr>
+          <a:xfrm>
+            <a:off x="548640" y="6355080"/>
+            <a:ext cx="11094415" cy="0"/>
+          </a:xfrm>
+          <a:prstGeom prst="line">
+            <a:avLst/>
+          </a:prstGeom>
+          <a:noFill/>
+          <a:ln w="9525">
+            <a:solidFill>
+              <a:srgbClr val="E2E8F0"/>
+            </a:solidFill>
+            <a:prstDash val="solid"/>
+          </a:ln>
+        </p:spPr>
+      </p:sp>
+      <p:sp>
+        <p:nvSpPr>
+          <p:cNvPr id="38" name="Text 35"/>
+          <p:cNvSpPr/>
+          <p:nvPr/>
+        </p:nvSpPr>
+        <p:spPr>
+          <a:xfrm>
+            <a:off x="548640" y="6446520"/>
+            <a:ext cx="5486400" cy="274320"/>
+          </a:xfrm>
+          <a:prstGeom prst="rect">
+            <a:avLst/>
+          </a:prstGeom>
+          <a:noFill/>
+          <a:ln/>
+        </p:spPr>
+        <p:txBody>
+          <a:bodyPr wrap="square" lIns="0" tIns="0" rIns="0" bIns="0" rtlCol="0" anchor="ctr"/>
+          <a:lstStyle/>
+          <a:p>
+            <a:pPr indent="0" marL="0">
+              <a:buNone/>
+            </a:pPr>
+            <a:r>
+              <a:rPr lang="en-US" sz="1300" dirty="0">
+                <a:solidFill>
+                  <a:srgbClr val="64748B"/>
+                </a:solidFill>
+                <a:latin typeface="Inter" pitchFamily="34" charset="0"/>
+                <a:ea typeface="Inter" pitchFamily="34" charset="-122"/>
+                <a:cs typeface="Inter" pitchFamily="34" charset="-120"/>
+              </a:rPr>
+              <a:t>PhDapp · for students</a:t>
+            </a:r>
+            <a:endParaRPr lang="en-US" sz="1300" dirty="0"/>
+          </a:p>
+        </p:txBody>
+      </p:sp>
+      <p:sp>
+        <p:nvSpPr>
+          <p:cNvPr id="39" name="Text 36"/>
+          <p:cNvSpPr/>
+          <p:nvPr/>
+        </p:nvSpPr>
+        <p:spPr>
+          <a:xfrm>
+            <a:off x="9814255" y="6446520"/>
+            <a:ext cx="1828800" cy="274320"/>
+          </a:xfrm>
+          <a:prstGeom prst="rect">
+            <a:avLst/>
+          </a:prstGeom>
+          <a:noFill/>
+          <a:ln/>
+        </p:spPr>
+        <p:txBody>
+          <a:bodyPr wrap="square" lIns="0" tIns="0" rIns="0" bIns="0" rtlCol="0" anchor="ctr"/>
+          <a:lstStyle/>
+          <a:p>
+            <a:pPr algn="r" indent="0" marL="0">
+              <a:buNone/>
+            </a:pPr>
+            <a:r>
+              <a:rPr lang="en-US" sz="1300" dirty="0">
+                <a:solidFill>
+                  <a:srgbClr val="64748B"/>
+                </a:solidFill>
+                <a:latin typeface="Inter" pitchFamily="34" charset="0"/>
+                <a:ea typeface="Inter" pitchFamily="34" charset="-122"/>
+                <a:cs typeface="Inter" pitchFamily="34" charset="-120"/>
+              </a:rPr>
+              <a:t>15 / 16</a:t>
+            </a:r>
+            <a:endParaRPr lang="en-US" sz="1300" dirty="0"/>
+          </a:p>
+        </p:txBody>
+      </p:sp>
+    </p:spTree>
+  </p:cSld>
+  <p:clrMapOvr>
+    <a:masterClrMapping/>
+  </p:clrMapOvr>
+</p:sld>
+</file>
+
+<file path=ppt/slides/slide16.xml><?xml version="1.0" encoding="utf-8"?>
+<p:sld xmlns:a="http://schemas.openxmlformats.org/drawingml/2006/main" xmlns:r="http://schemas.openxmlformats.org/officeDocument/2006/relationships" xmlns:p="http://schemas.openxmlformats.org/presentationml/2006/main">
+  <p:cSld name="Slide 16">
+    <p:bg>
+      <p:bgPr>
+        <a:solidFill>
+          <a:srgbClr val="FFFFFF"/>
+        </a:solidFill>
+      </p:bgPr>
+    </p:bg>
+    <p:spTree>
+      <p:nvGrpSpPr>
+        <p:cNvPr id="1" name=""/>
+        <p:cNvGrpSpPr/>
+        <p:nvPr/>
+      </p:nvGrpSpPr>
+      <p:grpSpPr>
+        <a:xfrm>
+          <a:off x="0" y="0"/>
+          <a:ext cx="0" cy="0"/>
+          <a:chOff x="0" y="0"/>
+          <a:chExt cx="0" cy="0"/>
+        </a:xfrm>
+      </p:grpSpPr>
+      <p:sp>
+        <p:nvSpPr>
+          <p:cNvPr id="2" name="Shape 0"/>
+          <p:cNvSpPr/>
+          <p:nvPr/>
+        </p:nvSpPr>
+        <p:spPr>
+          <a:xfrm>
+            <a:off x="548640" y="548640"/>
+            <a:ext cx="548640" cy="548640"/>
+          </a:xfrm>
+          <a:prstGeom prst="roundRect">
+            <a:avLst>
+              <a:gd name="adj" fmla="val 20000"/>
+            </a:avLst>
+          </a:prstGeom>
+          <a:solidFill>
+            <a:srgbClr val="2196F3"/>
+          </a:solidFill>
+          <a:ln/>
+        </p:spPr>
+      </p:sp>
+      <p:pic>
+        <p:nvPicPr>
+          <p:cNvPr id="3" name="Image 0" descr="preencoded.png">    </p:cNvPr>
+          <p:cNvPicPr>
+            <a:picLocks noChangeAspect="1"/>
+          </p:cNvPicPr>
+          <p:nvPr/>
+        </p:nvPicPr>
+        <p:blipFill>
+          <a:blip r:embed="rId1"/>
+          <a:stretch>
+            <a:fillRect/>
+          </a:stretch>
+        </p:blipFill>
+        <p:spPr>
+          <a:xfrm>
+            <a:off x="667512" y="667512"/>
+            <a:ext cx="310896" cy="310896"/>
+          </a:xfrm>
+          <a:prstGeom prst="rect">
+            <a:avLst/>
+          </a:prstGeom>
+        </p:spPr>
+      </p:pic>
+      <p:sp>
+        <p:nvSpPr>
+          <p:cNvPr id="4" name="Text 1"/>
+          <p:cNvSpPr/>
+          <p:nvPr/>
+        </p:nvSpPr>
+        <p:spPr>
+          <a:xfrm>
+            <a:off x="1261872" y="530352"/>
+            <a:ext cx="3657600" cy="292608"/>
+          </a:xfrm>
+          <a:prstGeom prst="rect">
+            <a:avLst/>
+          </a:prstGeom>
+          <a:noFill/>
+          <a:ln/>
+        </p:spPr>
+        <p:txBody>
+          <a:bodyPr wrap="square" lIns="0" tIns="0" rIns="0" bIns="0" rtlCol="0" anchor="ctr"/>
+          <a:lstStyle/>
+          <a:p>
+            <a:pPr indent="0" marL="0">
+              <a:buNone/>
+            </a:pPr>
+            <a:r>
+              <a:rPr lang="en-US" sz="1400" b="1" spc="400" kern="0" dirty="0">
+                <a:solidFill>
+                  <a:srgbClr val="2196F3"/>
+                </a:solidFill>
+                <a:latin typeface="Inter" pitchFamily="34" charset="0"/>
+                <a:ea typeface="Inter" pitchFamily="34" charset="-122"/>
+                <a:cs typeface="Inter" pitchFamily="34" charset="-120"/>
+              </a:rPr>
+              <a:t>TIPS</a:t>
+            </a:r>
+            <a:endParaRPr lang="en-US" sz="1400" dirty="0"/>
+          </a:p>
+        </p:txBody>
+      </p:sp>
+      <p:sp>
+        <p:nvSpPr>
+          <p:cNvPr id="5" name="Text 2"/>
+          <p:cNvSpPr/>
+          <p:nvPr/>
+        </p:nvSpPr>
+        <p:spPr>
+          <a:xfrm>
+            <a:off x="1261872" y="749808"/>
+            <a:ext cx="10381183" cy="713232"/>
+          </a:xfrm>
+          <a:prstGeom prst="rect">
+            <a:avLst/>
+          </a:prstGeom>
+          <a:noFill/>
+          <a:ln/>
+        </p:spPr>
+        <p:txBody>
+          <a:bodyPr wrap="square" lIns="0" tIns="0" rIns="0" bIns="0" rtlCol="0" anchor="ctr"/>
+          <a:lstStyle/>
+          <a:p>
+            <a:pPr indent="0" marL="0">
+              <a:buNone/>
+            </a:pPr>
+            <a:r>
+              <a:rPr lang="en-US" sz="4000" b="1" dirty="0">
+                <a:solidFill>
+                  <a:srgbClr val="0F172A"/>
+                </a:solidFill>
+                <a:latin typeface="Inter" pitchFamily="34" charset="0"/>
+                <a:ea typeface="Inter" pitchFamily="34" charset="-122"/>
+                <a:cs typeface="Inter" pitchFamily="34" charset="-120"/>
+              </a:rPr>
+              <a:t>Tips · and if something breaks</a:t>
+            </a:r>
+            <a:endParaRPr lang="en-US" sz="4000" dirty="0"/>
+          </a:p>
+        </p:txBody>
+      </p:sp>
+      <p:sp>
+        <p:nvSpPr>
+          <p:cNvPr id="6" name="Shape 3"/>
+          <p:cNvSpPr/>
+          <p:nvPr/>
+        </p:nvSpPr>
+        <p:spPr>
+          <a:xfrm>
+            <a:off x="548640" y="1828800"/>
+            <a:ext cx="5486400" cy="3931920"/>
+          </a:xfrm>
+          <a:prstGeom prst="rect">
+            <a:avLst/>
+          </a:prstGeom>
+          <a:solidFill>
+            <a:srgbClr val="FFFFFF"/>
+          </a:solidFill>
+          <a:ln w="9525">
+            <a:solidFill>
+              <a:srgbClr val="E2E8F0"/>
+            </a:solidFill>
+            <a:prstDash val="solid"/>
+          </a:ln>
+          <a:effectLst>
+            <a:outerShdw sx="100000" sy="100000" kx="0" ky="0" algn="bl" rotWithShape="0" blurRad="76200" dist="12700" dir="5400000">
+              <a:srgbClr val="94A3B8">
+                <a:alpha val="12000"/>
+              </a:srgbClr>
+            </a:outerShdw>
+          </a:effectLst>
+        </p:spPr>
+      </p:sp>
+      <p:sp>
+        <p:nvSpPr>
+          <p:cNvPr id="7" name="Shape 4"/>
+          <p:cNvSpPr/>
+          <p:nvPr/>
+        </p:nvSpPr>
+        <p:spPr>
+          <a:xfrm>
+            <a:off x="548640" y="1828800"/>
             <a:ext cx="73152" cy="3931920"/>
           </a:xfrm>
           <a:prstGeom prst="rect">
             <a:avLst/>
           </a:prstGeom>
           <a:solidFill>
-            <a:srgbClr val="E2445C"/>
+            <a:srgbClr val="2196F3"/>
           </a:solidFill>
           <a:ln/>
         </p:spPr>
       </p:sp>
       <p:sp>
         <p:nvSpPr>
-          <p:cNvPr id="12" name="Text 9"/>
-          <p:cNvSpPr/>
-          <p:nvPr/>
-        </p:nvSpPr>
-        <p:spPr>
-          <a:xfrm>
-            <a:off x="6601968" y="1993392"/>
-            <a:ext cx="4922215" cy="594360"/>
+          <p:cNvPr id="8" name="Text 5"/>
+          <p:cNvSpPr/>
+          <p:nvPr/>
+        </p:nvSpPr>
+        <p:spPr>
+          <a:xfrm>
+            <a:off x="749808" y="1993392"/>
+            <a:ext cx="5166360" cy="594360"/>
           </a:xfrm>
           <a:prstGeom prst="rect">
             <a:avLst/>
@@ -6466,7 +7647,7 @@
                 <a:ea typeface="Inter" pitchFamily="34" charset="-122"/>
                 <a:cs typeface="Inter" pitchFamily="34" charset="-120"/>
               </a:rPr>
-              <a:t>If something breaks</a:t>
+              <a:t>Tips</a:t>
             </a:r>
             <a:endParaRPr lang="en-US" sz="2200" dirty="0"/>
           </a:p>
@@ -6474,14 +7655,14 @@
       </p:sp>
       <p:sp>
         <p:nvSpPr>
-          <p:cNvPr id="13" name="Text 10"/>
-          <p:cNvSpPr/>
-          <p:nvPr/>
-        </p:nvSpPr>
-        <p:spPr>
-          <a:xfrm>
-            <a:off x="6629400" y="2697480"/>
-            <a:ext cx="4876495" cy="2926080"/>
+          <p:cNvPr id="9" name="Text 6"/>
+          <p:cNvSpPr/>
+          <p:nvPr/>
+        </p:nvSpPr>
+        <p:spPr>
+          <a:xfrm>
+            <a:off x="777240" y="2697480"/>
+            <a:ext cx="5074920" cy="2926080"/>
           </a:xfrm>
           <a:prstGeom prst="rect">
             <a:avLst/>
@@ -6509,7 +7690,7 @@
                 <a:ea typeface="Inter" pitchFamily="34" charset="-122"/>
                 <a:cs typeface="Inter" pitchFamily="34" charset="-120"/>
               </a:rPr>
-              <a:t>‘Access blocked’ → ask your supervisor to add you.</a:t>
+              <a:t>Keep the tab open — fewer missed alerts.</a:t>
             </a:r>
             <a:endParaRPr lang="en-US" sz="1800" dirty="0"/>
           </a:p>
@@ -6530,7 +7711,7 @@
                 <a:ea typeface="Inter" pitchFamily="34" charset="-122"/>
                 <a:cs typeface="Inter" pitchFamily="34" charset="-120"/>
               </a:rPr>
-              <a:t>Calendar/Drive missing → sign out + back in.</a:t>
+              <a:t>Channels for back-and-forth; comments for tasks.</a:t>
             </a:r>
             <a:endParaRPr lang="en-US" sz="1800" dirty="0"/>
           </a:p>
@@ -6551,7 +7732,7 @@
                 <a:ea typeface="Inter" pitchFamily="34" charset="-122"/>
                 <a:cs typeface="Inter" pitchFamily="34" charset="-120"/>
               </a:rPr>
-              <a:t>Sync feels stale → reload the tab.</a:t>
+              <a:t>Tag tasks with priority + due date.</a:t>
             </a:r>
             <a:endParaRPr lang="en-US" sz="1800" dirty="0"/>
           </a:p>
@@ -6572,7 +7753,7 @@
                 <a:ea typeface="Inter" pitchFamily="34" charset="-122"/>
                 <a:cs typeface="Inter" pitchFamily="34" charset="-120"/>
               </a:rPr>
-              <a:t>Event time looks off → check your timezone.</a:t>
+              <a:t>Drop a weekly check-in even if quiet.</a:t>
             </a:r>
             <a:endParaRPr lang="en-US" sz="1800" dirty="0"/>
           </a:p>
@@ -6593,7 +7774,7 @@
                 <a:ea typeface="Inter" pitchFamily="34" charset="-122"/>
                 <a:cs typeface="Inter" pitchFamily="34" charset="-120"/>
               </a:rPr>
-              <a:t>Anything else → Feedback, type ‘Bug’.</a:t>
+              <a:t>Right-click events → add to your iCal / Calendar.</a:t>
             </a:r>
             <a:endParaRPr lang="en-US" sz="1800" dirty="0"/>
           </a:p>
@@ -6601,25 +7782,243 @@
       </p:sp>
       <p:sp>
         <p:nvSpPr>
-          <p:cNvPr id="14" name="Shape 11"/>
-          <p:cNvSpPr/>
-          <p:nvPr/>
-        </p:nvSpPr>
-        <p:spPr>
-          <a:xfrm>
-            <a:off x="548640" y="6355080"/>
-            <a:ext cx="11094415" cy="0"/>
-          </a:xfrm>
-          <a:prstGeom prst="line">
-            <a:avLst/>
-          </a:prstGeom>
-          <a:noFill/>
+          <p:cNvPr id="10" name="Shape 7"/>
+          <p:cNvSpPr/>
+          <p:nvPr/>
+        </p:nvSpPr>
+        <p:spPr>
+          <a:xfrm>
+            <a:off x="6400800" y="1828800"/>
+            <a:ext cx="5242255" cy="3931920"/>
+          </a:xfrm>
+          <a:prstGeom prst="rect">
+            <a:avLst/>
+          </a:prstGeom>
+          <a:solidFill>
+            <a:srgbClr val="FFFFFF"/>
+          </a:solidFill>
           <a:ln w="9525">
             <a:solidFill>
               <a:srgbClr val="E2E8F0"/>
             </a:solidFill>
             <a:prstDash val="solid"/>
           </a:ln>
+          <a:effectLst>
+            <a:outerShdw sx="100000" sy="100000" kx="0" ky="0" algn="bl" rotWithShape="0" blurRad="76200" dist="12700" dir="5400000">
+              <a:srgbClr val="94A3B8">
+                <a:alpha val="12000"/>
+              </a:srgbClr>
+            </a:outerShdw>
+          </a:effectLst>
+        </p:spPr>
+      </p:sp>
+      <p:sp>
+        <p:nvSpPr>
+          <p:cNvPr id="11" name="Shape 8"/>
+          <p:cNvSpPr/>
+          <p:nvPr/>
+        </p:nvSpPr>
+        <p:spPr>
+          <a:xfrm>
+            <a:off x="6400800" y="1828800"/>
+            <a:ext cx="73152" cy="3931920"/>
+          </a:xfrm>
+          <a:prstGeom prst="rect">
+            <a:avLst/>
+          </a:prstGeom>
+          <a:solidFill>
+            <a:srgbClr val="E2445C"/>
+          </a:solidFill>
+          <a:ln/>
+        </p:spPr>
+      </p:sp>
+      <p:sp>
+        <p:nvSpPr>
+          <p:cNvPr id="12" name="Text 9"/>
+          <p:cNvSpPr/>
+          <p:nvPr/>
+        </p:nvSpPr>
+        <p:spPr>
+          <a:xfrm>
+            <a:off x="6601968" y="1993392"/>
+            <a:ext cx="4922215" cy="594360"/>
+          </a:xfrm>
+          <a:prstGeom prst="rect">
+            <a:avLst/>
+          </a:prstGeom>
+          <a:noFill/>
+          <a:ln/>
+        </p:spPr>
+        <p:txBody>
+          <a:bodyPr wrap="square" lIns="0" tIns="0" rIns="0" bIns="0" rtlCol="0" anchor="ctr"/>
+          <a:lstStyle/>
+          <a:p>
+            <a:pPr indent="0" marL="0">
+              <a:buNone/>
+            </a:pPr>
+            <a:r>
+              <a:rPr lang="en-US" sz="2200" b="1" dirty="0">
+                <a:solidFill>
+                  <a:srgbClr val="0F172A"/>
+                </a:solidFill>
+                <a:latin typeface="Inter" pitchFamily="34" charset="0"/>
+                <a:ea typeface="Inter" pitchFamily="34" charset="-122"/>
+                <a:cs typeface="Inter" pitchFamily="34" charset="-120"/>
+              </a:rPr>
+              <a:t>If something breaks</a:t>
+            </a:r>
+            <a:endParaRPr lang="en-US" sz="2200" dirty="0"/>
+          </a:p>
+        </p:txBody>
+      </p:sp>
+      <p:sp>
+        <p:nvSpPr>
+          <p:cNvPr id="13" name="Text 10"/>
+          <p:cNvSpPr/>
+          <p:nvPr/>
+        </p:nvSpPr>
+        <p:spPr>
+          <a:xfrm>
+            <a:off x="6629400" y="2697480"/>
+            <a:ext cx="4876495" cy="2926080"/>
+          </a:xfrm>
+          <a:prstGeom prst="rect">
+            <a:avLst/>
+          </a:prstGeom>
+          <a:noFill/>
+          <a:ln/>
+        </p:spPr>
+        <p:txBody>
+          <a:bodyPr wrap="square" lIns="0" tIns="0" rIns="0" bIns="0" rtlCol="0" anchor="t"/>
+          <a:lstStyle/>
+          <a:p>
+            <a:pPr marL="342900" indent="-342900">
+              <a:spcAft>
+                <a:spcPts val="600"/>
+              </a:spcAft>
+              <a:buSzPct val="100000"/>
+              <a:buChar char="•"/>
+            </a:pPr>
+            <a:r>
+              <a:rPr lang="en-US" sz="1800" dirty="0">
+                <a:solidFill>
+                  <a:srgbClr val="334155"/>
+                </a:solidFill>
+                <a:latin typeface="Inter" pitchFamily="34" charset="0"/>
+                <a:ea typeface="Inter" pitchFamily="34" charset="-122"/>
+                <a:cs typeface="Inter" pitchFamily="34" charset="-120"/>
+              </a:rPr>
+              <a:t>‘Access blocked’ → ask your supervisor to add you.</a:t>
+            </a:r>
+            <a:endParaRPr lang="en-US" sz="1800" dirty="0"/>
+          </a:p>
+          <a:p>
+            <a:pPr marL="342900" indent="-342900">
+              <a:spcAft>
+                <a:spcPts val="600"/>
+              </a:spcAft>
+              <a:buSzPct val="100000"/>
+              <a:buChar char="•"/>
+            </a:pPr>
+            <a:r>
+              <a:rPr lang="en-US" sz="1800" dirty="0">
+                <a:solidFill>
+                  <a:srgbClr val="334155"/>
+                </a:solidFill>
+                <a:latin typeface="Inter" pitchFamily="34" charset="0"/>
+                <a:ea typeface="Inter" pitchFamily="34" charset="-122"/>
+                <a:cs typeface="Inter" pitchFamily="34" charset="-120"/>
+              </a:rPr>
+              <a:t>Calendar/Drive missing → sign out + back in.</a:t>
+            </a:r>
+            <a:endParaRPr lang="en-US" sz="1800" dirty="0"/>
+          </a:p>
+          <a:p>
+            <a:pPr marL="342900" indent="-342900">
+              <a:spcAft>
+                <a:spcPts val="600"/>
+              </a:spcAft>
+              <a:buSzPct val="100000"/>
+              <a:buChar char="•"/>
+            </a:pPr>
+            <a:r>
+              <a:rPr lang="en-US" sz="1800" dirty="0">
+                <a:solidFill>
+                  <a:srgbClr val="334155"/>
+                </a:solidFill>
+                <a:latin typeface="Inter" pitchFamily="34" charset="0"/>
+                <a:ea typeface="Inter" pitchFamily="34" charset="-122"/>
+                <a:cs typeface="Inter" pitchFamily="34" charset="-120"/>
+              </a:rPr>
+              <a:t>Sync feels stale → reload the tab.</a:t>
+            </a:r>
+            <a:endParaRPr lang="en-US" sz="1800" dirty="0"/>
+          </a:p>
+          <a:p>
+            <a:pPr marL="342900" indent="-342900">
+              <a:spcAft>
+                <a:spcPts val="600"/>
+              </a:spcAft>
+              <a:buSzPct val="100000"/>
+              <a:buChar char="•"/>
+            </a:pPr>
+            <a:r>
+              <a:rPr lang="en-US" sz="1800" dirty="0">
+                <a:solidFill>
+                  <a:srgbClr val="334155"/>
+                </a:solidFill>
+                <a:latin typeface="Inter" pitchFamily="34" charset="0"/>
+                <a:ea typeface="Inter" pitchFamily="34" charset="-122"/>
+                <a:cs typeface="Inter" pitchFamily="34" charset="-120"/>
+              </a:rPr>
+              <a:t>Event time looks off → check your timezone.</a:t>
+            </a:r>
+            <a:endParaRPr lang="en-US" sz="1800" dirty="0"/>
+          </a:p>
+          <a:p>
+            <a:pPr marL="342900" indent="-342900">
+              <a:spcAft>
+                <a:spcPts val="600"/>
+              </a:spcAft>
+              <a:buSzPct val="100000"/>
+              <a:buChar char="•"/>
+            </a:pPr>
+            <a:r>
+              <a:rPr lang="en-US" sz="1800" dirty="0">
+                <a:solidFill>
+                  <a:srgbClr val="334155"/>
+                </a:solidFill>
+                <a:latin typeface="Inter" pitchFamily="34" charset="0"/>
+                <a:ea typeface="Inter" pitchFamily="34" charset="-122"/>
+                <a:cs typeface="Inter" pitchFamily="34" charset="-120"/>
+              </a:rPr>
+              <a:t>Anything else → Feedback, type ‘Bug’.</a:t>
+            </a:r>
+            <a:endParaRPr lang="en-US" sz="1800" dirty="0"/>
+          </a:p>
+        </p:txBody>
+      </p:sp>
+      <p:sp>
+        <p:nvSpPr>
+          <p:cNvPr id="14" name="Shape 11"/>
+          <p:cNvSpPr/>
+          <p:nvPr/>
+        </p:nvSpPr>
+        <p:spPr>
+          <a:xfrm>
+            <a:off x="548640" y="6355080"/>
+            <a:ext cx="11094415" cy="0"/>
+          </a:xfrm>
+          <a:prstGeom prst="line">
+            <a:avLst/>
+          </a:prstGeom>
+          <a:noFill/>
+          <a:ln w="9525">
+            <a:solidFill>
+              <a:srgbClr val="E2E8F0"/>
+            </a:solidFill>
+            <a:prstDash val="solid"/>
+          </a:ln>
         </p:spPr>
       </p:sp>
       <p:sp>
@@ -6694,7 +8093,7 @@
                 <a:ea typeface="Inter" pitchFamily="34" charset="-122"/>
                 <a:cs typeface="Inter" pitchFamily="34" charset="-120"/>
               </a:rPr>
-              <a:t>15 / 15</a:t>
+              <a:t>16 / 16</a:t>
             </a:r>
             <a:endParaRPr lang="en-US" sz="1300" dirty="0"/>
           </a:p>
@@ -8054,7 +9453,7 @@
                 <a:ea typeface="Inter" pitchFamily="34" charset="-122"/>
                 <a:cs typeface="Inter" pitchFamily="34" charset="-120"/>
               </a:rPr>
-              <a:t>2 / 15</a:t>
+              <a:t>2 / 16</a:t>
             </a:r>
             <a:endParaRPr lang="en-US" sz="1300" dirty="0"/>
           </a:p>
@@ -8765,7 +10164,7 @@
                 <a:ea typeface="Inter" pitchFamily="34" charset="-122"/>
                 <a:cs typeface="Inter" pitchFamily="34" charset="-120"/>
               </a:rPr>
-              <a:t>3 / 15</a:t>
+              <a:t>3 / 16</a:t>
             </a:r>
             <a:endParaRPr lang="en-US" sz="1300" dirty="0"/>
           </a:p>
@@ -9771,7 +11170,7 @@
                 <a:ea typeface="Inter" pitchFamily="34" charset="-122"/>
                 <a:cs typeface="Inter" pitchFamily="34" charset="-120"/>
               </a:rPr>
-              <a:t>4 / 15</a:t>
+              <a:t>4 / 16</a:t>
             </a:r>
             <a:endParaRPr lang="en-US" sz="1300" dirty="0"/>
           </a:p>
@@ -10721,7 +12120,7 @@
                 <a:ea typeface="Inter" pitchFamily="34" charset="-122"/>
                 <a:cs typeface="Inter" pitchFamily="34" charset="-120"/>
               </a:rPr>
-              <a:t>5 / 15</a:t>
+              <a:t>5 / 16</a:t>
             </a:r>
             <a:endParaRPr lang="en-US" sz="1300" dirty="0"/>
           </a:p>
@@ -11435,7 +12834,7 @@
                 <a:ea typeface="Inter" pitchFamily="34" charset="-122"/>
                 <a:cs typeface="Inter" pitchFamily="34" charset="-120"/>
               </a:rPr>
-              <a:t>6 / 15</a:t>
+              <a:t>6 / 16</a:t>
             </a:r>
             <a:endParaRPr lang="en-US" sz="1300" dirty="0"/>
           </a:p>
@@ -12107,7 +13506,7 @@
                 <a:ea typeface="Inter" pitchFamily="34" charset="-122"/>
                 <a:cs typeface="Inter" pitchFamily="34" charset="-120"/>
               </a:rPr>
-              <a:t>7 / 15</a:t>
+              <a:t>7 / 16</a:t>
             </a:r>
             <a:endParaRPr lang="en-US" sz="1300" dirty="0"/>
           </a:p>
@@ -12818,7 +14217,7 @@
                 <a:ea typeface="Inter" pitchFamily="34" charset="-122"/>
                 <a:cs typeface="Inter" pitchFamily="34" charset="-120"/>
               </a:rPr>
-              <a:t>8 / 15</a:t>
+              <a:t>8 / 16</a:t>
             </a:r>
             <a:endParaRPr lang="en-US" sz="1300" dirty="0"/>
           </a:p>
@@ -13550,7 +14949,7 @@
                 <a:ea typeface="Inter" pitchFamily="34" charset="-122"/>
                 <a:cs typeface="Inter" pitchFamily="34" charset="-120"/>
               </a:rPr>
-              <a:t>9 / 15</a:t>
+              <a:t>9 / 16</a:t>
             </a:r>
             <a:endParaRPr lang="en-US" sz="1300" dirty="0"/>
           </a:p>

</xml_diff>

<commit_message>
docs(slides): refresh decks with calendar UX updates
Rebuilt both PhDapp_Student_Overview.pptx and
PhDapp_Supervisor_Overview.pptx via /tmp/build-phdapp-decks.js.
Three bullet refreshes:

Student deck — Calendar slide:
  - 'Task / Sub-task auto deadline entries' → now reads
    'all-day deadline entries, also synced to Google.'
  - Week/Day bullet rewritten to mention 24h coverage,
    auto-scroll, and the all-day strip above the hours.

Supervisor deck — Calendar & availability slide:
  - 'Re-assign a student via Edit' bullet replaced with
    'Tasks AND sub-task deadlines auto-sync as all-day Google
    entries.'
  - 'Threaded comments + Links list on every event' replaced
    with 'Week/Day view covers all 24h + all-day strip above
    hours.'
  - 'Times are timezone-stable across edit/save' replaced with
    'Admin → Maintenance → Calendar cleanup repairs legacy
    disparities.'

Co-Authored-By: Claude Opus 4.7 (1M context) <noreply@anthropic.com>
</commit_message>
<xml_diff>
--- a/docs/PhDapp_Student_Overview.pptx
+++ b/docs/PhDapp_Student_Overview.pptx
@@ -13835,7 +13835,7 @@
                 <a:ea typeface="Inter" pitchFamily="34" charset="-122"/>
                 <a:cs typeface="Inter" pitchFamily="34" charset="-120"/>
               </a:rPr>
-              <a:t>[Task]_… / [Sub-task]_… — auto deadline entries.</a:t>
+              <a:t>[Task]_… / [Sub-task]_… — all-day deadline entries, also synced to Google.</a:t>
             </a:r>
             <a:endParaRPr lang="en-US" sz="1800" dirty="0"/>
           </a:p>
@@ -14032,7 +14032,7 @@
                 <a:ea typeface="Inter" pitchFamily="34" charset="-122"/>
                 <a:cs typeface="Inter" pitchFamily="34" charset="-120"/>
               </a:rPr>
-              <a:t>Year / Month / Week / Day views.</a:t>
+              <a:t>Year / Month / Week / Day — Week/Day cover 24h and auto-scroll to the current hour.</a:t>
             </a:r>
             <a:endParaRPr lang="en-US" sz="1800" dirty="0"/>
           </a:p>
@@ -14053,7 +14053,7 @@
                 <a:ea typeface="Inter" pitchFamily="34" charset="-122"/>
                 <a:cs typeface="Inter" pitchFamily="34" charset="-120"/>
               </a:rPr>
-              <a:t>Threaded comments — reply, edit, delete.</a:t>
+              <a:t>All-day items show in a dedicated strip above the hour grid.</a:t>
             </a:r>
             <a:endParaRPr lang="en-US" sz="1800" dirty="0"/>
           </a:p>
@@ -14074,7 +14074,7 @@
                 <a:ea typeface="Inter" pitchFamily="34" charset="-122"/>
                 <a:cs typeface="Inter" pitchFamily="34" charset="-120"/>
               </a:rPr>
-              <a:t>Links list (Overleaf docs, references, websites).</a:t>
+              <a:t>Threaded comments — reply, edit, delete.</a:t>
             </a:r>
             <a:endParaRPr lang="en-US" sz="1800" dirty="0"/>
           </a:p>
@@ -14095,7 +14095,7 @@
                 <a:ea typeface="Inter" pitchFamily="34" charset="-122"/>
                 <a:cs typeface="Inter" pitchFamily="34" charset="-120"/>
               </a:rPr>
-              <a:t>Link an event to a Task — shows on the task too.</a:t>
+              <a:t>Links list (Overleaf docs, references, websites).</a:t>
             </a:r>
             <a:endParaRPr lang="en-US" sz="1800" dirty="0"/>
           </a:p>
@@ -14116,7 +14116,7 @@
                 <a:ea typeface="Inter" pitchFamily="34" charset="-122"/>
                 <a:cs typeface="Inter" pitchFamily="34" charset="-120"/>
               </a:rPr>
-              <a:t>Times always render in your browser's timezone.</a:t>
+              <a:t>Link an event to a Task — shows on the task too.</a:t>
             </a:r>
             <a:endParaRPr lang="en-US" sz="1800" dirty="0"/>
           </a:p>

</xml_diff>

<commit_message>
Slides: add a Discussions slide to both overview decks
New violet-accented "Discussions" slide inserted after Chat in each
deck (duplicated the Chat slide, recoloured green→violet, 💡 chip):

- Supervisor deck (now 20 slides, Discussions = 11): Start a topic
  (persistent, visibility, student tag) + Inside a topic (threaded
  discussion, Links, Drive folder, email-style comment attachments,
  pin/close/delete, 🔔 + sidebar badge).
- Student deck (now 17 slides, Discussions = 10): What you'll see
  (Whole-team topics, can't start but can join, permanent) +
  Email-style comments (text+images+documents, drag-and-drop, inline
  images / download links, reply/edit/delete own).

Page-number footers renumbered across both decks. Rendered + visually
QA'd; no overflow, theme consistent.

Co-Authored-By: Claude Opus 4.8 <noreply@anthropic.com>
</commit_message>
<xml_diff>
--- a/docs/PhDapp_Student_Overview.pptx
+++ b/docs/PhDapp_Student_Overview.pptx
@@ -14,6 +14,7 @@
     <p:sldId id="262" r:id="rId8"/>
     <p:sldId id="263" r:id="rId9"/>
     <p:sldId id="264" r:id="rId10"/>
+    <p:sldId id="272" r:id="rId23"/>
     <p:sldId id="265" r:id="rId11"/>
     <p:sldId id="266" r:id="rId12"/>
     <p:sldId id="267" r:id="rId13"/>
@@ -3016,7 +3017,7 @@
                 <a:ea typeface="Inter" pitchFamily="34" charset="-122"/>
                 <a:cs typeface="Inter" pitchFamily="34" charset="-120"/>
               </a:rPr>
-              <a:t>10 / 16</a:t>
+              <a:t>11 / 17</a:t>
             </a:r>
             <a:endParaRPr lang="en-US" sz="1300" dirty="0"/>
           </a:p>
@@ -3685,7 +3686,7 @@
                 <a:ea typeface="Inter" pitchFamily="34" charset="-122"/>
                 <a:cs typeface="Inter" pitchFamily="34" charset="-120"/>
               </a:rPr>
-              <a:t>11 / 16</a:t>
+              <a:t>12 / 17</a:t>
             </a:r>
             <a:endParaRPr lang="en-US" sz="1300" dirty="0"/>
           </a:p>
@@ -4354,7 +4355,7 @@
                 <a:ea typeface="Inter" pitchFamily="34" charset="-122"/>
                 <a:cs typeface="Inter" pitchFamily="34" charset="-120"/>
               </a:rPr>
-              <a:t>12 / 16</a:t>
+              <a:t>13 / 17</a:t>
             </a:r>
             <a:endParaRPr lang="en-US" sz="1300" dirty="0"/>
           </a:p>
@@ -5400,7 +5401,7 @@
                 <a:ea typeface="Inter" pitchFamily="34" charset="-122"/>
                 <a:cs typeface="Inter" pitchFamily="34" charset="-120"/>
               </a:rPr>
-              <a:t>13 / 16</a:t>
+              <a:t>14 / 17</a:t>
             </a:r>
             <a:endParaRPr lang="en-US" sz="1300" dirty="0"/>
           </a:p>
@@ -6090,7 +6091,7 @@
                 <a:ea typeface="Inter" pitchFamily="34" charset="-122"/>
                 <a:cs typeface="Inter" pitchFamily="34" charset="-120"/>
               </a:rPr>
-              <a:t>14 / 16</a:t>
+              <a:t>15 / 17</a:t>
             </a:r>
             <a:endParaRPr lang="en-US" sz="1300" dirty="0"/>
           </a:p>
@@ -7400,7 +7401,7 @@
                 <a:ea typeface="Inter" pitchFamily="34" charset="-122"/>
                 <a:cs typeface="Inter" pitchFamily="34" charset="-120"/>
               </a:rPr>
-              <a:t>15 / 16</a:t>
+              <a:t>16 / 17</a:t>
             </a:r>
             <a:endParaRPr lang="en-US" sz="1300" dirty="0"/>
           </a:p>
@@ -8093,7 +8094,751 @@
                 <a:ea typeface="Inter" pitchFamily="34" charset="-122"/>
                 <a:cs typeface="Inter" pitchFamily="34" charset="-120"/>
               </a:rPr>
-              <a:t>16 / 16</a:t>
+              <a:t>17 / 17</a:t>
+            </a:r>
+            <a:endParaRPr lang="en-US" sz="1300" dirty="0"/>
+          </a:p>
+        </p:txBody>
+      </p:sp>
+    </p:spTree>
+  </p:cSld>
+  <p:clrMapOvr>
+    <a:masterClrMapping/>
+  </p:clrMapOvr>
+</p:sld>
+</file>
+
+<file path=ppt/slides/slide17.xml><?xml version="1.0" encoding="utf-8"?>
+<p:sld xmlns:a="http://schemas.openxmlformats.org/drawingml/2006/main" xmlns:r="http://schemas.openxmlformats.org/officeDocument/2006/relationships" xmlns:p="http://schemas.openxmlformats.org/presentationml/2006/main">
+  <p:cSld name="Slide 9">
+    <p:bg>
+      <p:bgPr>
+        <a:solidFill>
+          <a:srgbClr val="FFFFFF"/>
+        </a:solidFill>
+      </p:bgPr>
+    </p:bg>
+    <p:spTree>
+      <p:nvGrpSpPr>
+        <p:cNvPr id="1" name=""/>
+        <p:cNvGrpSpPr/>
+        <p:nvPr/>
+      </p:nvGrpSpPr>
+      <p:grpSpPr>
+        <a:xfrm>
+          <a:off x="0" y="0"/>
+          <a:ext cx="0" cy="0"/>
+          <a:chOff x="0" y="0"/>
+          <a:chExt cx="0" cy="0"/>
+        </a:xfrm>
+      </p:grpSpPr>
+      <p:sp>
+        <p:nvSpPr>
+          <p:cNvPr id="2" name="Shape 0"/>
+          <p:cNvSpPr/>
+          <p:nvPr/>
+        </p:nvSpPr>
+        <p:spPr>
+          <a:xfrm>
+            <a:off x="548640" y="548640"/>
+            <a:ext cx="548640" cy="548640"/>
+          </a:xfrm>
+          <a:prstGeom prst="roundRect">
+            <a:avLst>
+              <a:gd name="adj" fmla="val 20000"/>
+            </a:avLst>
+          </a:prstGeom>
+          <a:solidFill>
+            <a:srgbClr val="6F4CFF"/>
+          </a:solidFill>
+          <a:ln/>
+        </p:spPr>
+      </p:sp>
+      <p:sp>
+        <p:nvSpPr>
+          <p:cNvPr id="3" name="Icon glyph"/>
+          <p:cNvSpPr/>
+          <p:nvPr/>
+        </p:nvSpPr>
+        <p:spPr>
+          <a:xfrm>
+            <a:off x="548640" y="548640"/>
+            <a:ext cx="548640" cy="548640"/>
+          </a:xfrm>
+          <a:prstGeom prst="rect">
+            <a:avLst/>
+          </a:prstGeom>
+          <a:noFill/>
+          <a:ln/>
+        </p:spPr>
+        <p:txBody>
+          <a:bodyPr wrap="square" lIns="0" tIns="0" rIns="0" bIns="0" rtlCol="0" anchor="ctr"/>
+          <a:lstStyle/>
+          <a:p>
+            <a:pPr algn="ctr" indent="0" marL="0">
+              <a:buNone/>
+            </a:pPr>
+            <a:r>
+              <a:rPr lang="en-US" sz="2400" b="1" dirty="0">
+                <a:solidFill>
+                  <a:srgbClr val="FFFFFF"/>
+                </a:solidFill>
+                <a:latin typeface="Inter" pitchFamily="34" charset="0"/>
+              </a:rPr>
+              <a:t>💡</a:t>
+            </a:r>
+          </a:p>
+        </p:txBody>
+      </p:sp>
+      <p:sp>
+        <p:nvSpPr>
+          <p:cNvPr id="4" name="Text 1"/>
+          <p:cNvSpPr/>
+          <p:nvPr/>
+        </p:nvSpPr>
+        <p:spPr>
+          <a:xfrm>
+            <a:off x="1261872" y="530352"/>
+            <a:ext cx="3657600" cy="292608"/>
+          </a:xfrm>
+          <a:prstGeom prst="rect">
+            <a:avLst/>
+          </a:prstGeom>
+          <a:noFill/>
+          <a:ln/>
+        </p:spPr>
+        <p:txBody>
+          <a:bodyPr wrap="square" lIns="0" tIns="0" rIns="0" bIns="0" rtlCol="0" anchor="ctr"/>
+          <a:lstStyle/>
+          <a:p>
+            <a:pPr indent="0" marL="0">
+              <a:buNone/>
+            </a:pPr>
+            <a:r>
+              <a:rPr lang="en-US" sz="1400" b="1" spc="400" kern="0" dirty="0">
+                <a:solidFill>
+                  <a:srgbClr val="6F4CFF"/>
+                </a:solidFill>
+                <a:latin typeface="Inter" pitchFamily="34" charset="0"/>
+                <a:ea typeface="Inter" pitchFamily="34" charset="-122"/>
+                <a:cs typeface="Inter" pitchFamily="34" charset="-120"/>
+              </a:rPr>
+              <a:t>DISCUSSIONS</a:t>
+            </a:r>
+            <a:endParaRPr lang="en-US" sz="1400" dirty="0"/>
+          </a:p>
+        </p:txBody>
+      </p:sp>
+      <p:sp>
+        <p:nvSpPr>
+          <p:cNvPr id="5" name="Text 2"/>
+          <p:cNvSpPr/>
+          <p:nvPr/>
+        </p:nvSpPr>
+        <p:spPr>
+          <a:xfrm>
+            <a:off x="1261872" y="749808"/>
+            <a:ext cx="10381183" cy="777240"/>
+          </a:xfrm>
+          <a:prstGeom prst="rect">
+            <a:avLst/>
+          </a:prstGeom>
+          <a:noFill/>
+          <a:ln/>
+        </p:spPr>
+        <p:txBody>
+          <a:bodyPr wrap="square" lIns="0" tIns="0" rIns="0" bIns="0" rtlCol="0" anchor="t"/>
+          <a:lstStyle/>
+          <a:p>
+            <a:pPr indent="0" marL="0">
+              <a:buNone/>
+            </a:pPr>
+            <a:r>
+              <a:rPr lang="en-US" sz="4000" b="1" dirty="0">
+                <a:solidFill>
+                  <a:srgbClr val="0F172A"/>
+                </a:solidFill>
+                <a:latin typeface="Inter" pitchFamily="34" charset="0"/>
+                <a:ea typeface="Inter" pitchFamily="34" charset="-122"/>
+                <a:cs typeface="Inter" pitchFamily="34" charset="-120"/>
+              </a:rPr>
+              <a:t>Discussions</a:t>
+            </a:r>
+            <a:endParaRPr lang="en-US" sz="4000" dirty="0"/>
+          </a:p>
+        </p:txBody>
+      </p:sp>
+      <p:sp>
+        <p:nvSpPr>
+          <p:cNvPr id="6" name="Text 3"/>
+          <p:cNvSpPr/>
+          <p:nvPr/>
+        </p:nvSpPr>
+        <p:spPr>
+          <a:xfrm>
+            <a:off x="548640" y="1508760"/>
+            <a:ext cx="11094415" cy="822960"/>
+          </a:xfrm>
+          <a:prstGeom prst="rect">
+            <a:avLst/>
+          </a:prstGeom>
+          <a:noFill/>
+          <a:ln/>
+        </p:spPr>
+        <p:txBody>
+          <a:bodyPr wrap="square" lIns="0" tIns="0" rIns="0" bIns="0" rtlCol="0" anchor="t"/>
+          <a:lstStyle/>
+          <a:p>
+            <a:pPr indent="0" marL="0">
+              <a:buNone/>
+            </a:pPr>
+            <a:r>
+              <a:rPr lang="en-US" sz="2000" i="1" dirty="0">
+                <a:solidFill>
+                  <a:srgbClr val="334155"/>
+                </a:solidFill>
+                <a:latin typeface="Inter" pitchFamily="34" charset="0"/>
+                <a:ea typeface="Inter" pitchFamily="34" charset="-122"/>
+                <a:cs typeface="Inter" pitchFamily="34" charset="-120"/>
+              </a:rPr>
+              <a:t>Topic threads your supervisors open up to the whole team — persistent, unlike chat.</a:t>
+            </a:r>
+            <a:endParaRPr lang="en-US" sz="2000" dirty="0"/>
+          </a:p>
+        </p:txBody>
+      </p:sp>
+      <p:sp>
+        <p:nvSpPr>
+          <p:cNvPr id="7" name="Shape 4"/>
+          <p:cNvSpPr/>
+          <p:nvPr/>
+        </p:nvSpPr>
+        <p:spPr>
+          <a:xfrm>
+            <a:off x="548640" y="1828800"/>
+            <a:ext cx="5486400" cy="3931920"/>
+          </a:xfrm>
+          <a:prstGeom prst="rect">
+            <a:avLst/>
+          </a:prstGeom>
+          <a:solidFill>
+            <a:srgbClr val="FFFFFF"/>
+          </a:solidFill>
+          <a:ln w="9525">
+            <a:solidFill>
+              <a:srgbClr val="E2E8F0"/>
+            </a:solidFill>
+            <a:prstDash val="solid"/>
+          </a:ln>
+          <a:effectLst>
+            <a:outerShdw sx="100000" sy="100000" kx="0" ky="0" algn="bl" rotWithShape="0" blurRad="76200" dist="12700" dir="5400000">
+              <a:srgbClr val="94A3B8">
+                <a:alpha val="12000"/>
+              </a:srgbClr>
+            </a:outerShdw>
+          </a:effectLst>
+        </p:spPr>
+      </p:sp>
+      <p:sp>
+        <p:nvSpPr>
+          <p:cNvPr id="8" name="Shape 5"/>
+          <p:cNvSpPr/>
+          <p:nvPr/>
+        </p:nvSpPr>
+        <p:spPr>
+          <a:xfrm>
+            <a:off x="548640" y="1828800"/>
+            <a:ext cx="73152" cy="3931920"/>
+          </a:xfrm>
+          <a:prstGeom prst="rect">
+            <a:avLst/>
+          </a:prstGeom>
+          <a:solidFill>
+            <a:srgbClr val="6F4CFF"/>
+          </a:solidFill>
+          <a:ln/>
+        </p:spPr>
+      </p:sp>
+      <p:sp>
+        <p:nvSpPr>
+          <p:cNvPr id="9" name="Text 6"/>
+          <p:cNvSpPr/>
+          <p:nvPr/>
+        </p:nvSpPr>
+        <p:spPr>
+          <a:xfrm>
+            <a:off x="749808" y="1993392"/>
+            <a:ext cx="5166360" cy="594360"/>
+          </a:xfrm>
+          <a:prstGeom prst="rect">
+            <a:avLst/>
+          </a:prstGeom>
+          <a:noFill/>
+          <a:ln/>
+        </p:spPr>
+        <p:txBody>
+          <a:bodyPr wrap="square" lIns="0" tIns="0" rIns="0" bIns="0" rtlCol="0" anchor="ctr"/>
+          <a:lstStyle/>
+          <a:p>
+            <a:pPr indent="0" marL="0">
+              <a:buNone/>
+            </a:pPr>
+            <a:r>
+              <a:rPr lang="en-US" sz="2200" b="1" dirty="0">
+                <a:solidFill>
+                  <a:srgbClr val="0F172A"/>
+                </a:solidFill>
+                <a:latin typeface="Inter" pitchFamily="34" charset="0"/>
+                <a:ea typeface="Inter" pitchFamily="34" charset="-122"/>
+                <a:cs typeface="Inter" pitchFamily="34" charset="-120"/>
+              </a:rPr>
+              <a:t>What you'll see</a:t>
+            </a:r>
+            <a:endParaRPr lang="en-US" sz="2200" dirty="0"/>
+          </a:p>
+        </p:txBody>
+      </p:sp>
+      <p:sp>
+        <p:nvSpPr>
+          <p:cNvPr id="10" name="Text 7"/>
+          <p:cNvSpPr/>
+          <p:nvPr/>
+        </p:nvSpPr>
+        <p:spPr>
+          <a:xfrm>
+            <a:off x="777240" y="2697480"/>
+            <a:ext cx="5074920" cy="2926080"/>
+          </a:xfrm>
+          <a:prstGeom prst="rect">
+            <a:avLst/>
+          </a:prstGeom>
+          <a:noFill/>
+          <a:ln/>
+        </p:spPr>
+        <p:txBody>
+          <a:bodyPr wrap="square" lIns="0" tIns="0" rIns="0" bIns="0" rtlCol="0" anchor="t"/>
+          <a:lstStyle/>
+          <a:p>
+            <a:pPr marL="342900" indent="-342900">
+              <a:spcAft>
+                <a:spcPts val="600"/>
+              </a:spcAft>
+              <a:buSzPct val="100000"/>
+              <a:buChar char="•"/>
+            </a:pPr>
+            <a:r>
+              <a:rPr lang="en-US" sz="1800" dirty="0">
+                <a:solidFill>
+                  <a:srgbClr val="334155"/>
+                </a:solidFill>
+                <a:latin typeface="Inter" pitchFamily="34" charset="0"/>
+                <a:ea typeface="Inter" pitchFamily="34" charset="-122"/>
+                <a:cs typeface="Inter" pitchFamily="34" charset="-120"/>
+              </a:rPr>
+              <a:t>Topics a supervisor marks ‘Whole team’ show up here.</a:t>
+            </a:r>
+            <a:endParaRPr lang="en-US" sz="1800" dirty="0"/>
+          </a:p>
+          <a:p>
+            <a:pPr marL="342900" indent="-342900">
+              <a:spcAft>
+                <a:spcPts val="600"/>
+              </a:spcAft>
+              <a:buSzPct val="100000"/>
+              <a:buChar char="•"/>
+            </a:pPr>
+            <a:r>
+              <a:rPr lang="en-US" sz="1800" dirty="0">
+                <a:solidFill>
+                  <a:srgbClr val="334155"/>
+                </a:solidFill>
+                <a:latin typeface="Inter" pitchFamily="34" charset="0"/>
+                <a:ea typeface="Inter" pitchFamily="34" charset="-122"/>
+                <a:cs typeface="Inter" pitchFamily="34" charset="-120"/>
+              </a:rPr>
+              <a:t>‘Supervisors only’ topics stay hidden from students.</a:t>
+            </a:r>
+            <a:endParaRPr lang="en-US" sz="1800" dirty="0"/>
+          </a:p>
+          <a:p>
+            <a:pPr marL="342900" indent="-342900">
+              <a:spcAft>
+                <a:spcPts val="600"/>
+              </a:spcAft>
+              <a:buSzPct val="100000"/>
+              <a:buChar char="•"/>
+            </a:pPr>
+            <a:r>
+              <a:rPr lang="en-US" sz="1800" dirty="0">
+                <a:solidFill>
+                  <a:srgbClr val="334155"/>
+                </a:solidFill>
+                <a:latin typeface="Inter" pitchFamily="34" charset="0"/>
+                <a:ea typeface="Inter" pitchFamily="34" charset="-122"/>
+                <a:cs typeface="Inter" pitchFamily="34" charset="-120"/>
+              </a:rPr>
+              <a:t>You can’t start a topic — but you can fully join in.</a:t>
+            </a:r>
+            <a:endParaRPr lang="en-US" sz="1800" dirty="0"/>
+          </a:p>
+          <a:p>
+            <a:pPr marL="342900" indent="-342900">
+              <a:spcAft>
+                <a:spcPts val="600"/>
+              </a:spcAft>
+              <a:buSzPct val="100000"/>
+              <a:buChar char="•"/>
+            </a:pPr>
+            <a:r>
+              <a:rPr lang="en-US" sz="1800" dirty="0">
+                <a:solidFill>
+                  <a:srgbClr val="334155"/>
+                </a:solidFill>
+                <a:latin typeface="Inter" pitchFamily="34" charset="0"/>
+                <a:ea typeface="Inter" pitchFamily="34" charset="-122"/>
+                <a:cs typeface="Inter" pitchFamily="34" charset="-120"/>
+              </a:rPr>
+              <a:t>Each topic keeps its links and documents permanently.</a:t>
+            </a:r>
+            <a:endParaRPr lang="en-US" sz="1800" dirty="0"/>
+          </a:p>
+          <a:p>
+            <a:pPr marL="342900" indent="-342900">
+              <a:spcAft>
+                <a:spcPts val="600"/>
+              </a:spcAft>
+              <a:buSzPct val="100000"/>
+              <a:buChar char="•"/>
+            </a:pPr>
+            <a:r>
+              <a:rPr lang="en-US" sz="1800" dirty="0">
+                <a:solidFill>
+                  <a:srgbClr val="334155"/>
+                </a:solidFill>
+                <a:latin typeface="Inter" pitchFamily="34" charset="0"/>
+                <a:ea typeface="Inter" pitchFamily="34" charset="-122"/>
+                <a:cs typeface="Inter" pitchFamily="34" charset="-120"/>
+              </a:rPr>
+              <a:t>A violet sidebar dot flags new topics or comments.</a:t>
+            </a:r>
+            <a:endParaRPr lang="en-US" sz="1800" dirty="0"/>
+          </a:p>
+        </p:txBody>
+      </p:sp>
+      <p:sp>
+        <p:nvSpPr>
+          <p:cNvPr id="11" name="Shape 8"/>
+          <p:cNvSpPr/>
+          <p:nvPr/>
+        </p:nvSpPr>
+        <p:spPr>
+          <a:xfrm>
+            <a:off x="6400800" y="1828800"/>
+            <a:ext cx="5242255" cy="3931920"/>
+          </a:xfrm>
+          <a:prstGeom prst="rect">
+            <a:avLst/>
+          </a:prstGeom>
+          <a:solidFill>
+            <a:srgbClr val="FFFFFF"/>
+          </a:solidFill>
+          <a:ln w="9525">
+            <a:solidFill>
+              <a:srgbClr val="E2E8F0"/>
+            </a:solidFill>
+            <a:prstDash val="solid"/>
+          </a:ln>
+          <a:effectLst>
+            <a:outerShdw sx="100000" sy="100000" kx="0" ky="0" algn="bl" rotWithShape="0" blurRad="76200" dist="12700" dir="5400000">
+              <a:srgbClr val="94A3B8">
+                <a:alpha val="12000"/>
+              </a:srgbClr>
+            </a:outerShdw>
+          </a:effectLst>
+        </p:spPr>
+      </p:sp>
+      <p:sp>
+        <p:nvSpPr>
+          <p:cNvPr id="12" name="Shape 9"/>
+          <p:cNvSpPr/>
+          <p:nvPr/>
+        </p:nvSpPr>
+        <p:spPr>
+          <a:xfrm>
+            <a:off x="6400800" y="1828800"/>
+            <a:ext cx="73152" cy="3931920"/>
+          </a:xfrm>
+          <a:prstGeom prst="rect">
+            <a:avLst/>
+          </a:prstGeom>
+          <a:solidFill>
+            <a:srgbClr val="6F4CFF"/>
+          </a:solidFill>
+          <a:ln/>
+        </p:spPr>
+      </p:sp>
+      <p:sp>
+        <p:nvSpPr>
+          <p:cNvPr id="13" name="Text 10"/>
+          <p:cNvSpPr/>
+          <p:nvPr/>
+        </p:nvSpPr>
+        <p:spPr>
+          <a:xfrm>
+            <a:off x="6601968" y="1993392"/>
+            <a:ext cx="4922215" cy="594360"/>
+          </a:xfrm>
+          <a:prstGeom prst="rect">
+            <a:avLst/>
+          </a:prstGeom>
+          <a:noFill/>
+          <a:ln/>
+        </p:spPr>
+        <p:txBody>
+          <a:bodyPr wrap="square" lIns="0" tIns="0" rIns="0" bIns="0" rtlCol="0" anchor="ctr"/>
+          <a:lstStyle/>
+          <a:p>
+            <a:pPr indent="0" marL="0">
+              <a:buNone/>
+            </a:pPr>
+            <a:r>
+              <a:rPr lang="en-US" sz="2200" b="1" dirty="0">
+                <a:solidFill>
+                  <a:srgbClr val="0F172A"/>
+                </a:solidFill>
+                <a:latin typeface="Inter" pitchFamily="34" charset="0"/>
+                <a:ea typeface="Inter" pitchFamily="34" charset="-122"/>
+                <a:cs typeface="Inter" pitchFamily="34" charset="-120"/>
+              </a:rPr>
+              <a:t>Email-style comments</a:t>
+            </a:r>
+            <a:endParaRPr lang="en-US" sz="2200" dirty="0"/>
+          </a:p>
+        </p:txBody>
+      </p:sp>
+      <p:sp>
+        <p:nvSpPr>
+          <p:cNvPr id="14" name="Text 11"/>
+          <p:cNvSpPr/>
+          <p:nvPr/>
+        </p:nvSpPr>
+        <p:spPr>
+          <a:xfrm>
+            <a:off x="6629400" y="2697480"/>
+            <a:ext cx="4876495" cy="2926080"/>
+          </a:xfrm>
+          <a:prstGeom prst="rect">
+            <a:avLst/>
+          </a:prstGeom>
+          <a:noFill/>
+          <a:ln/>
+        </p:spPr>
+        <p:txBody>
+          <a:bodyPr wrap="square" lIns="0" tIns="0" rIns="0" bIns="0" rtlCol="0" anchor="t"/>
+          <a:lstStyle/>
+          <a:p>
+            <a:pPr marL="342900" indent="-342900">
+              <a:spcAft>
+                <a:spcPts val="600"/>
+              </a:spcAft>
+              <a:buSzPct val="100000"/>
+              <a:buChar char="•"/>
+            </a:pPr>
+            <a:r>
+              <a:rPr lang="en-US" sz="1800" dirty="0">
+                <a:solidFill>
+                  <a:srgbClr val="334155"/>
+                </a:solidFill>
+                <a:latin typeface="Inter" pitchFamily="34" charset="0"/>
+                <a:ea typeface="Inter" pitchFamily="34" charset="-122"/>
+                <a:cs typeface="Inter" pitchFamily="34" charset="-120"/>
+              </a:rPr>
+              <a:t>Write text plus images plus documents — like an email.</a:t>
+            </a:r>
+            <a:endParaRPr lang="en-US" sz="1800" dirty="0"/>
+          </a:p>
+          <a:p>
+            <a:pPr marL="342900" indent="-342900">
+              <a:spcAft>
+                <a:spcPts val="600"/>
+              </a:spcAft>
+              <a:buSzPct val="100000"/>
+              <a:buChar char="•"/>
+            </a:pPr>
+            <a:r>
+              <a:rPr lang="en-US" sz="1800" dirty="0">
+                <a:solidFill>
+                  <a:srgbClr val="334155"/>
+                </a:solidFill>
+                <a:latin typeface="Inter" pitchFamily="34" charset="0"/>
+                <a:ea typeface="Inter" pitchFamily="34" charset="-122"/>
+                <a:cs typeface="Inter" pitchFamily="34" charset="-120"/>
+              </a:rPr>
+              <a:t>Attach files or drag-and-drop (up to 25 MB each).</a:t>
+            </a:r>
+            <a:endParaRPr lang="en-US" sz="1800" dirty="0"/>
+          </a:p>
+          <a:p>
+            <a:pPr marL="342900" indent="-342900">
+              <a:spcAft>
+                <a:spcPts val="600"/>
+              </a:spcAft>
+              <a:buSzPct val="100000"/>
+              <a:buChar char="•"/>
+            </a:pPr>
+            <a:r>
+              <a:rPr lang="en-US" sz="1800" dirty="0">
+                <a:solidFill>
+                  <a:srgbClr val="334155"/>
+                </a:solidFill>
+                <a:latin typeface="Inter" pitchFamily="34" charset="0"/>
+                <a:ea typeface="Inter" pitchFamily="34" charset="-122"/>
+                <a:cs typeface="Inter" pitchFamily="34" charset="-120"/>
+              </a:rPr>
+              <a:t>Post a comment that’s just an attachment if you like.</a:t>
+            </a:r>
+            <a:endParaRPr lang="en-US" sz="1800" dirty="0"/>
+          </a:p>
+          <a:p>
+            <a:pPr marL="342900" indent="-342900">
+              <a:spcAft>
+                <a:spcPts val="600"/>
+              </a:spcAft>
+              <a:buSzPct val="100000"/>
+              <a:buChar char="•"/>
+            </a:pPr>
+            <a:r>
+              <a:rPr lang="en-US" sz="1800" dirty="0">
+                <a:solidFill>
+                  <a:srgbClr val="334155"/>
+                </a:solidFill>
+                <a:latin typeface="Inter" pitchFamily="34" charset="0"/>
+                <a:ea typeface="Inter" pitchFamily="34" charset="-122"/>
+                <a:cs typeface="Inter" pitchFamily="34" charset="-120"/>
+              </a:rPr>
+              <a:t>Images show inline; documents as download links.</a:t>
+            </a:r>
+            <a:endParaRPr lang="en-US" sz="1800" dirty="0"/>
+          </a:p>
+          <a:p>
+            <a:pPr marL="342900" indent="-342900">
+              <a:spcAft>
+                <a:spcPts val="600"/>
+              </a:spcAft>
+              <a:buSzPct val="100000"/>
+              <a:buChar char="•"/>
+            </a:pPr>
+            <a:r>
+              <a:rPr lang="en-US" sz="1800" dirty="0">
+                <a:solidFill>
+                  <a:srgbClr val="334155"/>
+                </a:solidFill>
+                <a:latin typeface="Inter" pitchFamily="34" charset="0"/>
+                <a:ea typeface="Inter" pitchFamily="34" charset="-122"/>
+                <a:cs typeface="Inter" pitchFamily="34" charset="-120"/>
+              </a:rPr>
+              <a:t>Reply to comments; edit or delete your own.</a:t>
+            </a:r>
+            <a:endParaRPr lang="en-US" sz="1800" dirty="0"/>
+          </a:p>
+        </p:txBody>
+      </p:sp>
+      <p:sp>
+        <p:nvSpPr>
+          <p:cNvPr id="15" name="Shape 12"/>
+          <p:cNvSpPr/>
+          <p:nvPr/>
+        </p:nvSpPr>
+        <p:spPr>
+          <a:xfrm>
+            <a:off x="548640" y="6355080"/>
+            <a:ext cx="11094415" cy="0"/>
+          </a:xfrm>
+          <a:prstGeom prst="line">
+            <a:avLst/>
+          </a:prstGeom>
+          <a:noFill/>
+          <a:ln w="9525">
+            <a:solidFill>
+              <a:srgbClr val="E2E8F0"/>
+            </a:solidFill>
+            <a:prstDash val="solid"/>
+          </a:ln>
+        </p:spPr>
+      </p:sp>
+      <p:sp>
+        <p:nvSpPr>
+          <p:cNvPr id="16" name="Text 13"/>
+          <p:cNvSpPr/>
+          <p:nvPr/>
+        </p:nvSpPr>
+        <p:spPr>
+          <a:xfrm>
+            <a:off x="548640" y="6446520"/>
+            <a:ext cx="5486400" cy="274320"/>
+          </a:xfrm>
+          <a:prstGeom prst="rect">
+            <a:avLst/>
+          </a:prstGeom>
+          <a:noFill/>
+          <a:ln/>
+        </p:spPr>
+        <p:txBody>
+          <a:bodyPr wrap="square" lIns="0" tIns="0" rIns="0" bIns="0" rtlCol="0" anchor="ctr"/>
+          <a:lstStyle/>
+          <a:p>
+            <a:pPr indent="0" marL="0">
+              <a:buNone/>
+            </a:pPr>
+            <a:r>
+              <a:rPr lang="en-US" sz="1300" dirty="0">
+                <a:solidFill>
+                  <a:srgbClr val="64748B"/>
+                </a:solidFill>
+                <a:latin typeface="Inter" pitchFamily="34" charset="0"/>
+                <a:ea typeface="Inter" pitchFamily="34" charset="-122"/>
+                <a:cs typeface="Inter" pitchFamily="34" charset="-120"/>
+              </a:rPr>
+              <a:t>PhDapp · for students</a:t>
+            </a:r>
+            <a:endParaRPr lang="en-US" sz="1300" dirty="0"/>
+          </a:p>
+        </p:txBody>
+      </p:sp>
+      <p:sp>
+        <p:nvSpPr>
+          <p:cNvPr id="17" name="Text 14"/>
+          <p:cNvSpPr/>
+          <p:nvPr/>
+        </p:nvSpPr>
+        <p:spPr>
+          <a:xfrm>
+            <a:off x="9814255" y="6446520"/>
+            <a:ext cx="1828800" cy="274320"/>
+          </a:xfrm>
+          <a:prstGeom prst="rect">
+            <a:avLst/>
+          </a:prstGeom>
+          <a:noFill/>
+          <a:ln/>
+        </p:spPr>
+        <p:txBody>
+          <a:bodyPr wrap="square" lIns="0" tIns="0" rIns="0" bIns="0" rtlCol="0" anchor="ctr"/>
+          <a:lstStyle/>
+          <a:p>
+            <a:pPr algn="r" indent="0" marL="0">
+              <a:buNone/>
+            </a:pPr>
+            <a:r>
+              <a:rPr lang="en-US" sz="1300" dirty="0">
+                <a:solidFill>
+                  <a:srgbClr val="64748B"/>
+                </a:solidFill>
+                <a:latin typeface="Inter" pitchFamily="34" charset="0"/>
+                <a:ea typeface="Inter" pitchFamily="34" charset="-122"/>
+                <a:cs typeface="Inter" pitchFamily="34" charset="-120"/>
+              </a:rPr>
+              <a:t>10 / 17</a:t>
             </a:r>
             <a:endParaRPr lang="en-US" sz="1300" dirty="0"/>
           </a:p>
@@ -9453,7 +10198,7 @@
                 <a:ea typeface="Inter" pitchFamily="34" charset="-122"/>
                 <a:cs typeface="Inter" pitchFamily="34" charset="-120"/>
               </a:rPr>
-              <a:t>2 / 16</a:t>
+              <a:t>2 / 17</a:t>
             </a:r>
             <a:endParaRPr lang="en-US" sz="1300" dirty="0"/>
           </a:p>
@@ -10164,7 +10909,7 @@
                 <a:ea typeface="Inter" pitchFamily="34" charset="-122"/>
                 <a:cs typeface="Inter" pitchFamily="34" charset="-120"/>
               </a:rPr>
-              <a:t>3 / 16</a:t>
+              <a:t>3 / 17</a:t>
             </a:r>
             <a:endParaRPr lang="en-US" sz="1300" dirty="0"/>
           </a:p>
@@ -11170,7 +11915,7 @@
                 <a:ea typeface="Inter" pitchFamily="34" charset="-122"/>
                 <a:cs typeface="Inter" pitchFamily="34" charset="-120"/>
               </a:rPr>
-              <a:t>4 / 16</a:t>
+              <a:t>4 / 17</a:t>
             </a:r>
             <a:endParaRPr lang="en-US" sz="1300" dirty="0"/>
           </a:p>
@@ -12120,7 +12865,7 @@
                 <a:ea typeface="Inter" pitchFamily="34" charset="-122"/>
                 <a:cs typeface="Inter" pitchFamily="34" charset="-120"/>
               </a:rPr>
-              <a:t>5 / 16</a:t>
+              <a:t>5 / 17</a:t>
             </a:r>
             <a:endParaRPr lang="en-US" sz="1300" dirty="0"/>
           </a:p>
@@ -12813,7 +13558,7 @@
                 <a:ea typeface="Inter" pitchFamily="34" charset="-122"/>
                 <a:cs typeface="Inter" pitchFamily="34" charset="-120"/>
               </a:rPr>
-              <a:t>6 / 16</a:t>
+              <a:t>6 / 17</a:t>
             </a:r>
             <a:endParaRPr lang="en-US" sz="1300" dirty="0"/>
           </a:p>
@@ -13485,7 +14230,7 @@
                 <a:ea typeface="Inter" pitchFamily="34" charset="-122"/>
                 <a:cs typeface="Inter" pitchFamily="34" charset="-120"/>
               </a:rPr>
-              <a:t>7 / 16</a:t>
+              <a:t>7 / 17</a:t>
             </a:r>
             <a:endParaRPr lang="en-US" sz="1300" dirty="0"/>
           </a:p>
@@ -14196,7 +14941,7 @@
                 <a:ea typeface="Inter" pitchFamily="34" charset="-122"/>
                 <a:cs typeface="Inter" pitchFamily="34" charset="-120"/>
               </a:rPr>
-              <a:t>8 / 16</a:t>
+              <a:t>8 / 17</a:t>
             </a:r>
             <a:endParaRPr lang="en-US" sz="1300" dirty="0"/>
           </a:p>
@@ -14928,7 +15673,7 @@
                 <a:ea typeface="Inter" pitchFamily="34" charset="-122"/>
                 <a:cs typeface="Inter" pitchFamily="34" charset="-120"/>
               </a:rPr>
-              <a:t>9 / 16</a:t>
+              <a:t>9 / 17</a:t>
             </a:r>
             <a:endParaRPr lang="en-US" sz="1300" dirty="0"/>
           </a:p>

</xml_diff>

<commit_message>
Docs + slides: reword comments as document-style (interleaved blocks)
Replace the "email-style / attach files" framing with the new
document-style model (type → drop image → type more, blocks reorder):

- Supervisor & student manuals: the Discussions comment bullet now
  describes building a comment like a document (attach/paste/drag-drop
  inserts in place, reorder ↑/↓, remove ×, image-only allowed, works
  for replies + editing).
- Admin manual: changelog entry rewritten around Comment.blocks (the
  ordered document model) with body/attachments derived; DocumentComposer.
- Both overview decks: Discussions slide comment bullets updated
  ("Comments build like a document…"; student column retitled
  "Document-style comments"). Re-rendered + QA'd, no overflow.

Co-Authored-By: Claude Opus 4.8 <noreply@anthropic.com>
</commit_message>
<xml_diff>
--- a/docs/PhDapp_Student_Overview.pptx
+++ b/docs/PhDapp_Student_Overview.pptx
@@ -8610,7 +8610,7 @@
                 <a:ea typeface="Inter" pitchFamily="34" charset="-122"/>
                 <a:cs typeface="Inter" pitchFamily="34" charset="-120"/>
               </a:rPr>
-              <a:t>Email-style comments</a:t>
+              <a:t>Document-style comments</a:t>
             </a:r>
             <a:endParaRPr lang="en-US" sz="2200" dirty="0"/>
           </a:p>
@@ -8653,7 +8653,7 @@
                 <a:ea typeface="Inter" pitchFamily="34" charset="-122"/>
                 <a:cs typeface="Inter" pitchFamily="34" charset="-120"/>
               </a:rPr>
-              <a:t>Write text plus images plus documents — like an email.</a:t>
+              <a:t>Build a comment like a document — text, image, more text, in any order.</a:t>
             </a:r>
             <a:endParaRPr lang="en-US" sz="1800" dirty="0"/>
           </a:p>
@@ -8674,7 +8674,7 @@
                 <a:ea typeface="Inter" pitchFamily="34" charset="-122"/>
                 <a:cs typeface="Inter" pitchFamily="34" charset="-120"/>
               </a:rPr>
-              <a:t>Attach files or drag-and-drop (up to 25 MB each).</a:t>
+              <a:t>Attach, paste (⌘V), or drag-and-drop (up to 25 MB each).</a:t>
             </a:r>
             <a:endParaRPr lang="en-US" sz="1800" dirty="0"/>
           </a:p>
@@ -8695,7 +8695,7 @@
                 <a:ea typeface="Inter" pitchFamily="34" charset="-122"/>
                 <a:cs typeface="Inter" pitchFamily="34" charset="-120"/>
               </a:rPr>
-              <a:t>Post a comment that’s just an attachment if you like.</a:t>
+              <a:t>Reorder or remove any block; post an image-only comment.</a:t>
             </a:r>
             <a:endParaRPr lang="en-US" sz="1800" dirty="0"/>
           </a:p>

</xml_diff>